<commit_message>
Updated slide deck with capacity details
</commit_message>
<xml_diff>
--- a/Extract-Insight-Action-Architecture-Enterprise.pptx
+++ b/Extract-Insight-Action-Architecture-Enterprise.pptx
@@ -5,12 +5,13 @@
     <p:sldMasterId id="2147483648" r:id="rId1"/>
   </p:sldMasterIdLst>
   <p:notesMasterIdLst>
-    <p:notesMasterId r:id="rId5"/>
+    <p:notesMasterId r:id="rId6"/>
   </p:notesMasterIdLst>
   <p:sldIdLst>
     <p:sldId id="259" r:id="rId2"/>
     <p:sldId id="258" r:id="rId3"/>
-    <p:sldId id="260" r:id="rId4"/>
+    <p:sldId id="261" r:id="rId4"/>
+    <p:sldId id="260" r:id="rId5"/>
   </p:sldIdLst>
   <p:sldSz cx="12192000" cy="6858000"/>
   <p:notesSz cx="6858000" cy="12192000"/>
@@ -113,6 +114,7 @@
           <p14:sldIdLst>
             <p14:sldId id="259"/>
             <p14:sldId id="258"/>
+            <p14:sldId id="261"/>
           </p14:sldIdLst>
         </p14:section>
         <p14:section name="archive" id="{415FC4B5-2493-4045-B0DD-826EC23A97AC}">
@@ -132,7 +134,7 @@
 <file path=ppt/revisionInfo.xml><?xml version="1.0" encoding="utf-8"?>
 <p1510:revInfo xmlns:a="http://schemas.openxmlformats.org/drawingml/2006/main" xmlns:r="http://schemas.openxmlformats.org/officeDocument/2006/relationships" xmlns:p1510="http://schemas.microsoft.com/office/powerpoint/2015/10/main">
   <p1510:revLst>
-    <p1510:client id="{1F10ED71-ECC1-4389-93B1-594CA2AFE81F}" v="6" dt="2026-06-03T18:55:29.955"/>
+    <p1510:client id="{4559FCE9-27C1-41AA-92EE-8AA829695188}" v="11" dt="2026-06-25T21:49:09.805"/>
   </p1510:revLst>
 </p1510:revInfo>
 </file>
@@ -142,26 +144,12 @@
   <pc:docChgLst>
     <pc:chgData name="Tirthankar Barari (TR)" userId="e41d4ef3-c9c5-4f08-a494-4c3cb9d953aa" providerId="ADAL" clId="{FDA9B3D4-9EE2-49C8-BD6B-D26A18FAF216}"/>
     <pc:docChg chg="undo redo custSel addSld delSld modSld sldOrd addSection modSection">
-      <pc:chgData name="Tirthankar Barari (TR)" userId="e41d4ef3-c9c5-4f08-a494-4c3cb9d953aa" providerId="ADAL" clId="{FDA9B3D4-9EE2-49C8-BD6B-D26A18FAF216}" dt="2026-06-03T21:33:32.615" v="2091" actId="2696"/>
+      <pc:chgData name="Tirthankar Barari (TR)" userId="e41d4ef3-c9c5-4f08-a494-4c3cb9d953aa" providerId="ADAL" clId="{FDA9B3D4-9EE2-49C8-BD6B-D26A18FAF216}" dt="2026-06-25T21:52:05.194" v="3287" actId="20577"/>
       <pc:docMkLst>
         <pc:docMk/>
       </pc:docMkLst>
-      <pc:sldChg chg="modSp del mod">
-        <pc:chgData name="Tirthankar Barari (TR)" userId="e41d4ef3-c9c5-4f08-a494-4c3cb9d953aa" providerId="ADAL" clId="{FDA9B3D4-9EE2-49C8-BD6B-D26A18FAF216}" dt="2026-06-03T19:26:06.088" v="1773" actId="2696"/>
-        <pc:sldMkLst>
-          <pc:docMk/>
-          <pc:sldMk cId="0" sldId="256"/>
-        </pc:sldMkLst>
-      </pc:sldChg>
-      <pc:sldChg chg="modSp del mod">
-        <pc:chgData name="Tirthankar Barari (TR)" userId="e41d4ef3-c9c5-4f08-a494-4c3cb9d953aa" providerId="ADAL" clId="{FDA9B3D4-9EE2-49C8-BD6B-D26A18FAF216}" dt="2026-06-03T19:26:09.010" v="1774" actId="2696"/>
-        <pc:sldMkLst>
-          <pc:docMk/>
-          <pc:sldMk cId="0" sldId="257"/>
-        </pc:sldMkLst>
-      </pc:sldChg>
       <pc:sldChg chg="addSp delSp modSp add mod setBg">
-        <pc:chgData name="Tirthankar Barari (TR)" userId="e41d4ef3-c9c5-4f08-a494-4c3cb9d953aa" providerId="ADAL" clId="{FDA9B3D4-9EE2-49C8-BD6B-D26A18FAF216}" dt="2026-06-03T21:29:21.682" v="1978" actId="20577"/>
+        <pc:chgData name="Tirthankar Barari (TR)" userId="e41d4ef3-c9c5-4f08-a494-4c3cb9d953aa" providerId="ADAL" clId="{FDA9B3D4-9EE2-49C8-BD6B-D26A18FAF216}" dt="2026-06-25T20:02:33.610" v="2092" actId="26606"/>
         <pc:sldMkLst>
           <pc:docMk/>
           <pc:sldMk cId="4205993008" sldId="258"/>
@@ -630,22 +618,6 @@
             <ac:spMk id="74" creationId="{298FC74E-DD1A-F119-3CD6-ED13E51BBB25}"/>
           </ac:spMkLst>
         </pc:spChg>
-        <pc:spChg chg="del mod">
-          <ac:chgData name="Tirthankar Barari (TR)" userId="e41d4ef3-c9c5-4f08-a494-4c3cb9d953aa" providerId="ADAL" clId="{FDA9B3D4-9EE2-49C8-BD6B-D26A18FAF216}" dt="2026-06-02T21:46:17.432" v="767" actId="478"/>
-          <ac:spMkLst>
-            <pc:docMk/>
-            <pc:sldMk cId="4205993008" sldId="258"/>
-            <ac:spMk id="75" creationId="{4BE1EA52-F488-F0F3-E04C-EC804DD7DA4B}"/>
-          </ac:spMkLst>
-        </pc:spChg>
-        <pc:spChg chg="del mod">
-          <ac:chgData name="Tirthankar Barari (TR)" userId="e41d4ef3-c9c5-4f08-a494-4c3cb9d953aa" providerId="ADAL" clId="{FDA9B3D4-9EE2-49C8-BD6B-D26A18FAF216}" dt="2026-06-03T18:48:04.579" v="1574" actId="478"/>
-          <ac:spMkLst>
-            <pc:docMk/>
-            <pc:sldMk cId="4205993008" sldId="258"/>
-            <ac:spMk id="76" creationId="{820B0DCD-4120-046E-DE7B-2D773C536AFB}"/>
-          </ac:spMkLst>
-        </pc:spChg>
         <pc:spChg chg="mod">
           <ac:chgData name="Tirthankar Barari (TR)" userId="e41d4ef3-c9c5-4f08-a494-4c3cb9d953aa" providerId="ADAL" clId="{FDA9B3D4-9EE2-49C8-BD6B-D26A18FAF216}" dt="2026-06-03T21:17:48.538" v="1899" actId="26606"/>
           <ac:spMkLst>
@@ -662,76 +634,12 @@
             <ac:spMk id="78" creationId="{64FCF313-E890-A4A5-5F32-69ECAE176C7D}"/>
           </ac:spMkLst>
         </pc:spChg>
-        <pc:spChg chg="del">
-          <ac:chgData name="Tirthankar Barari (TR)" userId="e41d4ef3-c9c5-4f08-a494-4c3cb9d953aa" providerId="ADAL" clId="{FDA9B3D4-9EE2-49C8-BD6B-D26A18FAF216}" dt="2026-06-03T18:52:07.649" v="1639" actId="478"/>
-          <ac:spMkLst>
-            <pc:docMk/>
-            <pc:sldMk cId="4205993008" sldId="258"/>
-            <ac:spMk id="79" creationId="{64F998BD-7E69-1304-BD84-C3CED92C4BD0}"/>
-          </ac:spMkLst>
-        </pc:spChg>
-        <pc:spChg chg="del">
-          <ac:chgData name="Tirthankar Barari (TR)" userId="e41d4ef3-c9c5-4f08-a494-4c3cb9d953aa" providerId="ADAL" clId="{FDA9B3D4-9EE2-49C8-BD6B-D26A18FAF216}" dt="2026-06-03T18:55:04.273" v="1654" actId="478"/>
-          <ac:spMkLst>
-            <pc:docMk/>
-            <pc:sldMk cId="4205993008" sldId="258"/>
-            <ac:spMk id="80" creationId="{1CA0E221-0287-9AC9-34D0-3222096AE782}"/>
-          </ac:spMkLst>
-        </pc:spChg>
-        <pc:spChg chg="del mod">
-          <ac:chgData name="Tirthankar Barari (TR)" userId="e41d4ef3-c9c5-4f08-a494-4c3cb9d953aa" providerId="ADAL" clId="{FDA9B3D4-9EE2-49C8-BD6B-D26A18FAF216}" dt="2026-06-03T18:46:50.538" v="1547" actId="478"/>
-          <ac:spMkLst>
-            <pc:docMk/>
-            <pc:sldMk cId="4205993008" sldId="258"/>
-            <ac:spMk id="81" creationId="{2FB6409B-B6F2-8E16-F6D4-317FDC51070C}"/>
-          </ac:spMkLst>
-        </pc:spChg>
-        <pc:spChg chg="del mod">
-          <ac:chgData name="Tirthankar Barari (TR)" userId="e41d4ef3-c9c5-4f08-a494-4c3cb9d953aa" providerId="ADAL" clId="{FDA9B3D4-9EE2-49C8-BD6B-D26A18FAF216}" dt="2026-06-03T18:52:04.392" v="1638" actId="478"/>
-          <ac:spMkLst>
-            <pc:docMk/>
-            <pc:sldMk cId="4205993008" sldId="258"/>
-            <ac:spMk id="82" creationId="{E6DC781A-458A-BFB1-811B-E98EBA2AE7C3}"/>
-          </ac:spMkLst>
-        </pc:spChg>
         <pc:spChg chg="mod">
           <ac:chgData name="Tirthankar Barari (TR)" userId="e41d4ef3-c9c5-4f08-a494-4c3cb9d953aa" providerId="ADAL" clId="{FDA9B3D4-9EE2-49C8-BD6B-D26A18FAF216}" dt="2026-06-03T19:09:56.371" v="1703" actId="1076"/>
           <ac:spMkLst>
             <pc:docMk/>
             <pc:sldMk cId="4205993008" sldId="258"/>
             <ac:spMk id="83" creationId="{2AB3D2FA-AE74-E052-E9FC-F276A9B2F14D}"/>
-          </ac:spMkLst>
-        </pc:spChg>
-        <pc:spChg chg="add del mod">
-          <ac:chgData name="Tirthankar Barari (TR)" userId="e41d4ef3-c9c5-4f08-a494-4c3cb9d953aa" providerId="ADAL" clId="{FDA9B3D4-9EE2-49C8-BD6B-D26A18FAF216}" dt="2026-06-03T17:34:00.813" v="887" actId="26606"/>
-          <ac:spMkLst>
-            <pc:docMk/>
-            <pc:sldMk cId="4205993008" sldId="258"/>
-            <ac:spMk id="85" creationId="{96C51593-1DBF-5186-4109-9B775FEAF4A1}"/>
-          </ac:spMkLst>
-        </pc:spChg>
-        <pc:spChg chg="add del mod">
-          <ac:chgData name="Tirthankar Barari (TR)" userId="e41d4ef3-c9c5-4f08-a494-4c3cb9d953aa" providerId="ADAL" clId="{FDA9B3D4-9EE2-49C8-BD6B-D26A18FAF216}" dt="2026-06-02T21:31:46.158" v="685" actId="478"/>
-          <ac:spMkLst>
-            <pc:docMk/>
-            <pc:sldMk cId="4205993008" sldId="258"/>
-            <ac:spMk id="86" creationId="{C4F7D069-2C45-70ED-F6CE-402B5638455A}"/>
-          </ac:spMkLst>
-        </pc:spChg>
-        <pc:spChg chg="add mod">
-          <ac:chgData name="Tirthankar Barari (TR)" userId="e41d4ef3-c9c5-4f08-a494-4c3cb9d953aa" providerId="ADAL" clId="{FDA9B3D4-9EE2-49C8-BD6B-D26A18FAF216}" dt="2026-06-03T17:53:39.099" v="1029" actId="571"/>
-          <ac:spMkLst>
-            <pc:docMk/>
-            <pc:sldMk cId="4205993008" sldId="258"/>
-            <ac:spMk id="90" creationId="{2A8CA509-D646-5B0B-E81C-C0542136C036}"/>
-          </ac:spMkLst>
-        </pc:spChg>
-        <pc:spChg chg="add del">
-          <ac:chgData name="Tirthankar Barari (TR)" userId="e41d4ef3-c9c5-4f08-a494-4c3cb9d953aa" providerId="ADAL" clId="{FDA9B3D4-9EE2-49C8-BD6B-D26A18FAF216}" dt="2026-06-02T19:55:18.277" v="550" actId="22"/>
-          <ac:spMkLst>
-            <pc:docMk/>
-            <pc:sldMk cId="4205993008" sldId="258"/>
-            <ac:spMk id="90" creationId="{B501E757-9DAD-68F5-2C13-F8453E76C934}"/>
           </ac:spMkLst>
         </pc:spChg>
         <pc:spChg chg="add mod">
@@ -742,44 +650,12 @@
             <ac:spMk id="92" creationId="{4A90B66A-CBA3-3840-DC39-0281359031EF}"/>
           </ac:spMkLst>
         </pc:spChg>
-        <pc:spChg chg="mod">
-          <ac:chgData name="Tirthankar Barari (TR)" userId="e41d4ef3-c9c5-4f08-a494-4c3cb9d953aa" providerId="ADAL" clId="{FDA9B3D4-9EE2-49C8-BD6B-D26A18FAF216}" dt="2026-06-03T17:53:39.099" v="1029" actId="571"/>
-          <ac:spMkLst>
-            <pc:docMk/>
-            <pc:sldMk cId="4205993008" sldId="258"/>
-            <ac:spMk id="93" creationId="{29ACDABA-7EB0-B8CD-26BA-1209AE1DCFBE}"/>
-          </ac:spMkLst>
-        </pc:spChg>
-        <pc:spChg chg="mod">
-          <ac:chgData name="Tirthankar Barari (TR)" userId="e41d4ef3-c9c5-4f08-a494-4c3cb9d953aa" providerId="ADAL" clId="{FDA9B3D4-9EE2-49C8-BD6B-D26A18FAF216}" dt="2026-06-03T17:53:39.099" v="1029" actId="571"/>
-          <ac:spMkLst>
-            <pc:docMk/>
-            <pc:sldMk cId="4205993008" sldId="258"/>
-            <ac:spMk id="102" creationId="{5F988946-0553-8C38-2CAC-1A79F86588E8}"/>
-          </ac:spMkLst>
-        </pc:spChg>
-        <pc:spChg chg="add del mod ord">
-          <ac:chgData name="Tirthankar Barari (TR)" userId="e41d4ef3-c9c5-4f08-a494-4c3cb9d953aa" providerId="ADAL" clId="{FDA9B3D4-9EE2-49C8-BD6B-D26A18FAF216}" dt="2026-06-02T21:32:54.923" v="691" actId="478"/>
-          <ac:spMkLst>
-            <pc:docMk/>
-            <pc:sldMk cId="4205993008" sldId="258"/>
-            <ac:spMk id="102" creationId="{F0560BC3-68D1-B7A6-2EAE-96AF40EDF3F3}"/>
-          </ac:spMkLst>
-        </pc:spChg>
         <pc:spChg chg="add mod">
           <ac:chgData name="Tirthankar Barari (TR)" userId="e41d4ef3-c9c5-4f08-a494-4c3cb9d953aa" providerId="ADAL" clId="{FDA9B3D4-9EE2-49C8-BD6B-D26A18FAF216}" dt="2026-06-03T17:48:12.705" v="1004" actId="14100"/>
           <ac:spMkLst>
             <pc:docMk/>
             <pc:sldMk cId="4205993008" sldId="258"/>
             <ac:spMk id="103" creationId="{BDE6F27B-8967-45D1-4C6D-32C922B61C21}"/>
-          </ac:spMkLst>
-        </pc:spChg>
-        <pc:spChg chg="mod">
-          <ac:chgData name="Tirthankar Barari (TR)" userId="e41d4ef3-c9c5-4f08-a494-4c3cb9d953aa" providerId="ADAL" clId="{FDA9B3D4-9EE2-49C8-BD6B-D26A18FAF216}" dt="2026-06-03T17:53:39.099" v="1029" actId="571"/>
-          <ac:spMkLst>
-            <pc:docMk/>
-            <pc:sldMk cId="4205993008" sldId="258"/>
-            <ac:spMk id="104" creationId="{C79ECD99-208B-564E-D7F8-F7B904046349}"/>
           </ac:spMkLst>
         </pc:spChg>
         <pc:spChg chg="add mod">
@@ -790,68 +666,12 @@
             <ac:spMk id="105" creationId="{D25DADC7-649F-9EEB-92F4-663E056BE6DF}"/>
           </ac:spMkLst>
         </pc:spChg>
-        <pc:spChg chg="add del mod">
-          <ac:chgData name="Tirthankar Barari (TR)" userId="e41d4ef3-c9c5-4f08-a494-4c3cb9d953aa" providerId="ADAL" clId="{FDA9B3D4-9EE2-49C8-BD6B-D26A18FAF216}" dt="2026-06-03T19:22:43.664" v="1719" actId="478"/>
-          <ac:spMkLst>
-            <pc:docMk/>
-            <pc:sldMk cId="4205993008" sldId="258"/>
-            <ac:spMk id="108" creationId="{6EE983C4-69EC-ACFF-03B8-5BD3E25549EC}"/>
-          </ac:spMkLst>
-        </pc:spChg>
-        <pc:spChg chg="mod">
-          <ac:chgData name="Tirthankar Barari (TR)" userId="e41d4ef3-c9c5-4f08-a494-4c3cb9d953aa" providerId="ADAL" clId="{FDA9B3D4-9EE2-49C8-BD6B-D26A18FAF216}" dt="2026-06-03T17:53:39.099" v="1029" actId="571"/>
-          <ac:spMkLst>
-            <pc:docMk/>
-            <pc:sldMk cId="4205993008" sldId="258"/>
-            <ac:spMk id="109" creationId="{F4A70532-EF52-852A-4FDC-44D1C106B92E}"/>
-          </ac:spMkLst>
-        </pc:spChg>
-        <pc:spChg chg="add del mod">
-          <ac:chgData name="Tirthankar Barari (TR)" userId="e41d4ef3-c9c5-4f08-a494-4c3cb9d953aa" providerId="ADAL" clId="{FDA9B3D4-9EE2-49C8-BD6B-D26A18FAF216}" dt="2026-06-02T21:46:12.870" v="766" actId="478"/>
-          <ac:spMkLst>
-            <pc:docMk/>
-            <pc:sldMk cId="4205993008" sldId="258"/>
-            <ac:spMk id="110" creationId="{EDB071BE-3CA1-CC3D-2136-18D169538FAF}"/>
-          </ac:spMkLst>
-        </pc:spChg>
-        <pc:spChg chg="mod">
-          <ac:chgData name="Tirthankar Barari (TR)" userId="e41d4ef3-c9c5-4f08-a494-4c3cb9d953aa" providerId="ADAL" clId="{FDA9B3D4-9EE2-49C8-BD6B-D26A18FAF216}" dt="2026-06-03T17:53:39.099" v="1029" actId="571"/>
-          <ac:spMkLst>
-            <pc:docMk/>
-            <pc:sldMk cId="4205993008" sldId="258"/>
-            <ac:spMk id="110" creationId="{EDE73D1E-7B53-83FE-FA6A-E5F8F08CA9B2}"/>
-          </ac:spMkLst>
-        </pc:spChg>
-        <pc:spChg chg="mod">
-          <ac:chgData name="Tirthankar Barari (TR)" userId="e41d4ef3-c9c5-4f08-a494-4c3cb9d953aa" providerId="ADAL" clId="{FDA9B3D4-9EE2-49C8-BD6B-D26A18FAF216}" dt="2026-06-03T17:53:39.099" v="1029" actId="571"/>
-          <ac:spMkLst>
-            <pc:docMk/>
-            <pc:sldMk cId="4205993008" sldId="258"/>
-            <ac:spMk id="111" creationId="{E9C3D3DD-CAB3-E512-0868-FE20EB5FC5F4}"/>
-          </ac:spMkLst>
-        </pc:spChg>
         <pc:spChg chg="add mod ord">
           <ac:chgData name="Tirthankar Barari (TR)" userId="e41d4ef3-c9c5-4f08-a494-4c3cb9d953aa" providerId="ADAL" clId="{FDA9B3D4-9EE2-49C8-BD6B-D26A18FAF216}" dt="2026-06-03T21:17:48.538" v="1899" actId="26606"/>
           <ac:spMkLst>
             <pc:docMk/>
             <pc:sldMk cId="4205993008" sldId="258"/>
             <ac:spMk id="112" creationId="{53F3C587-3EB2-6169-0098-B95F00F1513E}"/>
-          </ac:spMkLst>
-        </pc:spChg>
-        <pc:spChg chg="add del mod">
-          <ac:chgData name="Tirthankar Barari (TR)" userId="e41d4ef3-c9c5-4f08-a494-4c3cb9d953aa" providerId="ADAL" clId="{FDA9B3D4-9EE2-49C8-BD6B-D26A18FAF216}" dt="2026-06-02T21:36:39.410" v="720" actId="478"/>
-          <ac:spMkLst>
-            <pc:docMk/>
-            <pc:sldMk cId="4205993008" sldId="258"/>
-            <ac:spMk id="114" creationId="{B9A9FE77-DD4E-461E-2116-AEBD34A01BD3}"/>
-          </ac:spMkLst>
-        </pc:spChg>
-        <pc:spChg chg="add del mod">
-          <ac:chgData name="Tirthankar Barari (TR)" userId="e41d4ef3-c9c5-4f08-a494-4c3cb9d953aa" providerId="ADAL" clId="{FDA9B3D4-9EE2-49C8-BD6B-D26A18FAF216}" dt="2026-06-02T21:36:49.614" v="722" actId="478"/>
-          <ac:spMkLst>
-            <pc:docMk/>
-            <pc:sldMk cId="4205993008" sldId="258"/>
-            <ac:spMk id="116" creationId="{B05C153E-AA14-BED4-4AAB-330BEBF4CEA9}"/>
           </ac:spMkLst>
         </pc:spChg>
         <pc:spChg chg="add mod ord">
@@ -884,14 +704,6 @@
             <pc:docMk/>
             <pc:sldMk cId="4205993008" sldId="258"/>
             <ac:spMk id="122" creationId="{1CE701F1-BBB0-3BD8-640C-DB4F5BA01D97}"/>
-          </ac:spMkLst>
-        </pc:spChg>
-        <pc:spChg chg="add del">
-          <ac:chgData name="Tirthankar Barari (TR)" userId="e41d4ef3-c9c5-4f08-a494-4c3cb9d953aa" providerId="ADAL" clId="{FDA9B3D4-9EE2-49C8-BD6B-D26A18FAF216}" dt="2026-06-02T21:37:25.659" v="727" actId="22"/>
-          <ac:spMkLst>
-            <pc:docMk/>
-            <pc:sldMk cId="4205993008" sldId="258"/>
-            <ac:spMk id="122" creationId="{69502965-706C-518D-522C-076818589476}"/>
           </ac:spMkLst>
         </pc:spChg>
         <pc:spChg chg="mod topLvl">
@@ -958,14 +770,6 @@
             <ac:spMk id="136" creationId="{4D77666F-8DF8-55DB-7843-A3943C5D9ACD}"/>
           </ac:spMkLst>
         </pc:spChg>
-        <pc:spChg chg="add del mod">
-          <ac:chgData name="Tirthankar Barari (TR)" userId="e41d4ef3-c9c5-4f08-a494-4c3cb9d953aa" providerId="ADAL" clId="{FDA9B3D4-9EE2-49C8-BD6B-D26A18FAF216}" dt="2026-06-03T19:22:38.829" v="1718" actId="478"/>
-          <ac:spMkLst>
-            <pc:docMk/>
-            <pc:sldMk cId="4205993008" sldId="258"/>
-            <ac:spMk id="141" creationId="{CF8684BC-2271-E0F3-4D55-78D59A4226A2}"/>
-          </ac:spMkLst>
-        </pc:spChg>
         <pc:spChg chg="add mod">
           <ac:chgData name="Tirthankar Barari (TR)" userId="e41d4ef3-c9c5-4f08-a494-4c3cb9d953aa" providerId="ADAL" clId="{FDA9B3D4-9EE2-49C8-BD6B-D26A18FAF216}" dt="2026-06-03T21:17:48.538" v="1899" actId="26606"/>
           <ac:spMkLst>
@@ -1007,14 +811,6 @@
           </ac:grpSpMkLst>
         </pc:grpChg>
         <pc:grpChg chg="add mod">
-          <ac:chgData name="Tirthankar Barari (TR)" userId="e41d4ef3-c9c5-4f08-a494-4c3cb9d953aa" providerId="ADAL" clId="{FDA9B3D4-9EE2-49C8-BD6B-D26A18FAF216}" dt="2026-06-03T17:53:39.099" v="1029" actId="571"/>
-          <ac:grpSpMkLst>
-            <pc:docMk/>
-            <pc:sldMk cId="4205993008" sldId="258"/>
-            <ac:grpSpMk id="91" creationId="{4E96221E-A5F9-1ACE-D5E9-86EC3396A1C5}"/>
-          </ac:grpSpMkLst>
-        </pc:grpChg>
-        <pc:grpChg chg="add mod">
           <ac:chgData name="Tirthankar Barari (TR)" userId="e41d4ef3-c9c5-4f08-a494-4c3cb9d953aa" providerId="ADAL" clId="{FDA9B3D4-9EE2-49C8-BD6B-D26A18FAF216}" dt="2026-06-03T18:39:04.315" v="1510" actId="1076"/>
           <ac:grpSpMkLst>
             <pc:docMk/>
@@ -1031,7 +827,7 @@
           </ac:grpSpMkLst>
         </pc:grpChg>
         <pc:grpChg chg="add mod">
-          <ac:chgData name="Tirthankar Barari (TR)" userId="e41d4ef3-c9c5-4f08-a494-4c3cb9d953aa" providerId="ADAL" clId="{FDA9B3D4-9EE2-49C8-BD6B-D26A18FAF216}" dt="2026-06-03T18:21:08.950" v="1369" actId="1076"/>
+          <ac:chgData name="Tirthankar Barari (TR)" userId="e41d4ef3-c9c5-4f08-a494-4c3cb9d953aa" providerId="ADAL" clId="{FDA9B3D4-9EE2-49C8-BD6B-D26A18FAF216}" dt="2026-06-25T20:02:33.610" v="2092" actId="26606"/>
           <ac:grpSpMkLst>
             <pc:docMk/>
             <pc:sldMk cId="4205993008" sldId="258"/>
@@ -1039,7 +835,7 @@
           </ac:grpSpMkLst>
         </pc:grpChg>
         <pc:grpChg chg="add mod">
-          <ac:chgData name="Tirthankar Barari (TR)" userId="e41d4ef3-c9c5-4f08-a494-4c3cb9d953aa" providerId="ADAL" clId="{FDA9B3D4-9EE2-49C8-BD6B-D26A18FAF216}" dt="2026-06-03T18:21:08.950" v="1369" actId="1076"/>
+          <ac:chgData name="Tirthankar Barari (TR)" userId="e41d4ef3-c9c5-4f08-a494-4c3cb9d953aa" providerId="ADAL" clId="{FDA9B3D4-9EE2-49C8-BD6B-D26A18FAF216}" dt="2026-06-25T20:02:33.610" v="2092" actId="26606"/>
           <ac:grpSpMkLst>
             <pc:docMk/>
             <pc:sldMk cId="4205993008" sldId="258"/>
@@ -1047,7 +843,7 @@
           </ac:grpSpMkLst>
         </pc:grpChg>
         <pc:grpChg chg="add mod">
-          <ac:chgData name="Tirthankar Barari (TR)" userId="e41d4ef3-c9c5-4f08-a494-4c3cb9d953aa" providerId="ADAL" clId="{FDA9B3D4-9EE2-49C8-BD6B-D26A18FAF216}" dt="2026-06-03T18:21:08.950" v="1369" actId="1076"/>
+          <ac:chgData name="Tirthankar Barari (TR)" userId="e41d4ef3-c9c5-4f08-a494-4c3cb9d953aa" providerId="ADAL" clId="{FDA9B3D4-9EE2-49C8-BD6B-D26A18FAF216}" dt="2026-06-25T20:02:33.610" v="2092" actId="26606"/>
           <ac:grpSpMkLst>
             <pc:docMk/>
             <pc:sldMk cId="4205993008" sldId="258"/>
@@ -1055,7 +851,7 @@
           </ac:grpSpMkLst>
         </pc:grpChg>
         <pc:grpChg chg="add mod">
-          <ac:chgData name="Tirthankar Barari (TR)" userId="e41d4ef3-c9c5-4f08-a494-4c3cb9d953aa" providerId="ADAL" clId="{FDA9B3D4-9EE2-49C8-BD6B-D26A18FAF216}" dt="2026-06-03T18:14:42.163" v="1181" actId="1076"/>
+          <ac:chgData name="Tirthankar Barari (TR)" userId="e41d4ef3-c9c5-4f08-a494-4c3cb9d953aa" providerId="ADAL" clId="{FDA9B3D4-9EE2-49C8-BD6B-D26A18FAF216}" dt="2026-06-25T20:02:33.610" v="2092" actId="26606"/>
           <ac:grpSpMkLst>
             <pc:docMk/>
             <pc:sldMk cId="4205993008" sldId="258"/>
@@ -1063,15 +859,7 @@
           </ac:grpSpMkLst>
         </pc:grpChg>
         <pc:grpChg chg="add mod">
-          <ac:chgData name="Tirthankar Barari (TR)" userId="e41d4ef3-c9c5-4f08-a494-4c3cb9d953aa" providerId="ADAL" clId="{FDA9B3D4-9EE2-49C8-BD6B-D26A18FAF216}" dt="2026-06-03T17:53:39.099" v="1029" actId="571"/>
-          <ac:grpSpMkLst>
-            <pc:docMk/>
-            <pc:sldMk cId="4205993008" sldId="258"/>
-            <ac:grpSpMk id="107" creationId="{7A5BB5BA-B0A9-AB38-F615-2A6581F52892}"/>
-          </ac:grpSpMkLst>
-        </pc:grpChg>
-        <pc:grpChg chg="add mod">
-          <ac:chgData name="Tirthankar Barari (TR)" userId="e41d4ef3-c9c5-4f08-a494-4c3cb9d953aa" providerId="ADAL" clId="{FDA9B3D4-9EE2-49C8-BD6B-D26A18FAF216}" dt="2026-06-03T18:39:04.315" v="1510" actId="1076"/>
+          <ac:chgData name="Tirthankar Barari (TR)" userId="e41d4ef3-c9c5-4f08-a494-4c3cb9d953aa" providerId="ADAL" clId="{FDA9B3D4-9EE2-49C8-BD6B-D26A18FAF216}" dt="2026-06-25T20:02:33.610" v="2092" actId="26606"/>
           <ac:grpSpMkLst>
             <pc:docMk/>
             <pc:sldMk cId="4205993008" sldId="258"/>
@@ -1102,14 +890,6 @@
             <ac:grpSpMk id="116" creationId="{693EFA12-9739-4581-2D1F-DBDE2B2A361D}"/>
           </ac:grpSpMkLst>
         </pc:grpChg>
-        <pc:grpChg chg="add del mod">
-          <ac:chgData name="Tirthankar Barari (TR)" userId="e41d4ef3-c9c5-4f08-a494-4c3cb9d953aa" providerId="ADAL" clId="{FDA9B3D4-9EE2-49C8-BD6B-D26A18FAF216}" dt="2026-06-03T18:42:53.283" v="1531" actId="165"/>
-          <ac:grpSpMkLst>
-            <pc:docMk/>
-            <pc:sldMk cId="4205993008" sldId="258"/>
-            <ac:grpSpMk id="117" creationId="{621B59EB-55FE-F703-ED5A-4EC9A395B4C3}"/>
-          </ac:grpSpMkLst>
-        </pc:grpChg>
         <pc:grpChg chg="add mod ord">
           <ac:chgData name="Tirthankar Barari (TR)" userId="e41d4ef3-c9c5-4f08-a494-4c3cb9d953aa" providerId="ADAL" clId="{FDA9B3D4-9EE2-49C8-BD6B-D26A18FAF216}" dt="2026-06-03T18:23:04.101" v="1380" actId="14100"/>
           <ac:grpSpMkLst>
@@ -1118,24 +898,8 @@
             <ac:grpSpMk id="126" creationId="{FB1CE96C-CBA9-78C1-AADD-ECEC7271536F}"/>
           </ac:grpSpMkLst>
         </pc:grpChg>
-        <pc:grpChg chg="add del mod">
-          <ac:chgData name="Tirthankar Barari (TR)" userId="e41d4ef3-c9c5-4f08-a494-4c3cb9d953aa" providerId="ADAL" clId="{FDA9B3D4-9EE2-49C8-BD6B-D26A18FAF216}" dt="2026-06-03T18:42:48.036" v="1530" actId="165"/>
-          <ac:grpSpMkLst>
-            <pc:docMk/>
-            <pc:sldMk cId="4205993008" sldId="258"/>
-            <ac:grpSpMk id="127" creationId="{412CAD33-57C8-7747-F071-EFCCAE6B43B8}"/>
-          </ac:grpSpMkLst>
-        </pc:grpChg>
-        <pc:grpChg chg="add del mod">
-          <ac:chgData name="Tirthankar Barari (TR)" userId="e41d4ef3-c9c5-4f08-a494-4c3cb9d953aa" providerId="ADAL" clId="{FDA9B3D4-9EE2-49C8-BD6B-D26A18FAF216}" dt="2026-06-03T18:43:03.181" v="1532" actId="165"/>
-          <ac:grpSpMkLst>
-            <pc:docMk/>
-            <pc:sldMk cId="4205993008" sldId="258"/>
-            <ac:grpSpMk id="132" creationId="{166FD9AB-D540-5C9C-1745-D1C58B41B225}"/>
-          </ac:grpSpMkLst>
-        </pc:grpChg>
         <pc:grpChg chg="add mod">
-          <ac:chgData name="Tirthankar Barari (TR)" userId="e41d4ef3-c9c5-4f08-a494-4c3cb9d953aa" providerId="ADAL" clId="{FDA9B3D4-9EE2-49C8-BD6B-D26A18FAF216}" dt="2026-06-03T18:46:37.464" v="1545" actId="1076"/>
+          <ac:chgData name="Tirthankar Barari (TR)" userId="e41d4ef3-c9c5-4f08-a494-4c3cb9d953aa" providerId="ADAL" clId="{FDA9B3D4-9EE2-49C8-BD6B-D26A18FAF216}" dt="2026-06-25T20:02:33.610" v="2092" actId="26606"/>
           <ac:grpSpMkLst>
             <pc:docMk/>
             <pc:sldMk cId="4205993008" sldId="258"/>
@@ -1143,7 +907,7 @@
           </ac:grpSpMkLst>
         </pc:grpChg>
         <pc:grpChg chg="add mod">
-          <ac:chgData name="Tirthankar Barari (TR)" userId="e41d4ef3-c9c5-4f08-a494-4c3cb9d953aa" providerId="ADAL" clId="{FDA9B3D4-9EE2-49C8-BD6B-D26A18FAF216}" dt="2026-06-03T18:46:37.464" v="1545" actId="1076"/>
+          <ac:chgData name="Tirthankar Barari (TR)" userId="e41d4ef3-c9c5-4f08-a494-4c3cb9d953aa" providerId="ADAL" clId="{FDA9B3D4-9EE2-49C8-BD6B-D26A18FAF216}" dt="2026-06-25T20:02:33.610" v="2092" actId="26606"/>
           <ac:grpSpMkLst>
             <pc:docMk/>
             <pc:sldMk cId="4205993008" sldId="258"/>
@@ -1151,21 +915,13 @@
           </ac:grpSpMkLst>
         </pc:grpChg>
         <pc:grpChg chg="add mod">
-          <ac:chgData name="Tirthankar Barari (TR)" userId="e41d4ef3-c9c5-4f08-a494-4c3cb9d953aa" providerId="ADAL" clId="{FDA9B3D4-9EE2-49C8-BD6B-D26A18FAF216}" dt="2026-06-03T18:46:37.464" v="1545" actId="1076"/>
+          <ac:chgData name="Tirthankar Barari (TR)" userId="e41d4ef3-c9c5-4f08-a494-4c3cb9d953aa" providerId="ADAL" clId="{FDA9B3D4-9EE2-49C8-BD6B-D26A18FAF216}" dt="2026-06-25T20:02:33.610" v="2092" actId="26606"/>
           <ac:grpSpMkLst>
             <pc:docMk/>
             <pc:sldMk cId="4205993008" sldId="258"/>
             <ac:grpSpMk id="139" creationId="{7F9557EE-701B-8BEB-2708-37E9FD1FF8E5}"/>
           </ac:grpSpMkLst>
         </pc:grpChg>
-        <pc:picChg chg="add del mod">
-          <ac:chgData name="Tirthankar Barari (TR)" userId="e41d4ef3-c9c5-4f08-a494-4c3cb9d953aa" providerId="ADAL" clId="{FDA9B3D4-9EE2-49C8-BD6B-D26A18FAF216}" dt="2026-06-03T17:46:13.103" v="975" actId="478"/>
-          <ac:picMkLst>
-            <pc:docMk/>
-            <pc:sldMk cId="4205993008" sldId="258"/>
-            <ac:picMk id="26" creationId="{17061491-78DA-E679-5195-B275A5B681BD}"/>
-          </ac:picMkLst>
-        </pc:picChg>
         <pc:picChg chg="add">
           <ac:chgData name="Tirthankar Barari (TR)" userId="e41d4ef3-c9c5-4f08-a494-4c3cb9d953aa" providerId="ADAL" clId="{FDA9B3D4-9EE2-49C8-BD6B-D26A18FAF216}" dt="2026-05-29T17:51:09.424" v="306" actId="26606"/>
           <ac:picMkLst>
@@ -1180,14 +936,6 @@
             <pc:docMk/>
             <pc:sldMk cId="4205993008" sldId="258"/>
             <ac:picMk id="38" creationId="{E8864354-8EF7-12AF-9B6C-B1872AA81520}"/>
-          </ac:picMkLst>
-        </pc:picChg>
-        <pc:picChg chg="del mod">
-          <ac:chgData name="Tirthankar Barari (TR)" userId="e41d4ef3-c9c5-4f08-a494-4c3cb9d953aa" providerId="ADAL" clId="{FDA9B3D4-9EE2-49C8-BD6B-D26A18FAF216}" dt="2026-06-03T17:56:17.214" v="1043" actId="478"/>
-          <ac:picMkLst>
-            <pc:docMk/>
-            <pc:sldMk cId="4205993008" sldId="258"/>
-            <ac:picMk id="42" creationId="{21072411-3FF2-E3C1-F1B4-921FB84021D6}"/>
           </ac:picMkLst>
         </pc:picChg>
         <pc:picChg chg="mod">
@@ -1238,28 +986,12 @@
             <ac:picMk id="97" creationId="{B6A30158-AE7D-F80C-C4E2-E38FC5CDFD43}"/>
           </ac:picMkLst>
         </pc:picChg>
-        <pc:picChg chg="mod">
-          <ac:chgData name="Tirthankar Barari (TR)" userId="e41d4ef3-c9c5-4f08-a494-4c3cb9d953aa" providerId="ADAL" clId="{FDA9B3D4-9EE2-49C8-BD6B-D26A18FAF216}" dt="2026-06-03T17:53:39.099" v="1029" actId="571"/>
-          <ac:picMkLst>
-            <pc:docMk/>
-            <pc:sldMk cId="4205993008" sldId="258"/>
-            <ac:picMk id="101" creationId="{FC2E7792-576E-3BC3-C8C7-9A23AC110E9F}"/>
-          </ac:picMkLst>
-        </pc:picChg>
         <pc:picChg chg="mod topLvl">
           <ac:chgData name="Tirthankar Barari (TR)" userId="e41d4ef3-c9c5-4f08-a494-4c3cb9d953aa" providerId="ADAL" clId="{FDA9B3D4-9EE2-49C8-BD6B-D26A18FAF216}" dt="2026-06-03T18:43:32.111" v="1536" actId="554"/>
           <ac:picMkLst>
             <pc:docMk/>
             <pc:sldMk cId="4205993008" sldId="258"/>
             <ac:picMk id="121" creationId="{EBAF7FDE-7A07-CFDE-8FE1-689A479AA74C}"/>
-          </ac:picMkLst>
-        </pc:picChg>
-        <pc:picChg chg="add del mod">
-          <ac:chgData name="Tirthankar Barari (TR)" userId="e41d4ef3-c9c5-4f08-a494-4c3cb9d953aa" providerId="ADAL" clId="{FDA9B3D4-9EE2-49C8-BD6B-D26A18FAF216}" dt="2026-06-03T17:36:52.496" v="896" actId="478"/>
-          <ac:picMkLst>
-            <pc:docMk/>
-            <pc:sldMk cId="4205993008" sldId="258"/>
-            <ac:picMk id="125" creationId="{00000000-0000-0000-0000-000000000000}"/>
           </ac:picMkLst>
         </pc:picChg>
         <pc:picChg chg="mod topLvl">
@@ -1469,139 +1201,100 @@
             <ac:spMk id="49" creationId="{00000000-0000-0000-0000-000000000000}"/>
           </ac:spMkLst>
         </pc:spChg>
-        <pc:spChg chg="mod replId">
-          <ac:chgData name="Tirthankar Barari (TR)" userId="e41d4ef3-c9c5-4f08-a494-4c3cb9d953aa" providerId="ADAL" clId="{FDA9B3D4-9EE2-49C8-BD6B-D26A18FAF216}" dt="2026-06-03T19:47:53.705" v="1826" actId="26606"/>
-          <ac:spMkLst>
-            <pc:docMk/>
-            <pc:sldMk cId="0" sldId="259"/>
-            <ac:spMk id="51" creationId="{00000000-0000-0000-0000-000000000000}"/>
-          </ac:spMkLst>
-        </pc:spChg>
-        <pc:spChg chg="mod replId">
-          <ac:chgData name="Tirthankar Barari (TR)" userId="e41d4ef3-c9c5-4f08-a494-4c3cb9d953aa" providerId="ADAL" clId="{FDA9B3D4-9EE2-49C8-BD6B-D26A18FAF216}" dt="2026-06-03T19:51:46.968" v="1828" actId="26606"/>
-          <ac:spMkLst>
-            <pc:docMk/>
-            <pc:sldMk cId="0" sldId="259"/>
-            <ac:spMk id="52" creationId="{00000000-0000-0000-0000-000000000000}"/>
-          </ac:spMkLst>
-        </pc:spChg>
-        <pc:spChg chg="mod replId">
-          <ac:chgData name="Tirthankar Barari (TR)" userId="e41d4ef3-c9c5-4f08-a494-4c3cb9d953aa" providerId="ADAL" clId="{FDA9B3D4-9EE2-49C8-BD6B-D26A18FAF216}" dt="2026-06-03T19:47:53.705" v="1826" actId="26606"/>
-          <ac:spMkLst>
-            <pc:docMk/>
-            <pc:sldMk cId="0" sldId="259"/>
-            <ac:spMk id="53" creationId="{00000000-0000-0000-0000-000000000000}"/>
-          </ac:spMkLst>
-        </pc:spChg>
-        <pc:spChg chg="mod replId">
-          <ac:chgData name="Tirthankar Barari (TR)" userId="e41d4ef3-c9c5-4f08-a494-4c3cb9d953aa" providerId="ADAL" clId="{FDA9B3D4-9EE2-49C8-BD6B-D26A18FAF216}" dt="2026-06-03T19:51:46.968" v="1828" actId="26606"/>
-          <ac:spMkLst>
-            <pc:docMk/>
-            <pc:sldMk cId="0" sldId="259"/>
-            <ac:spMk id="54" creationId="{00000000-0000-0000-0000-000000000000}"/>
-          </ac:spMkLst>
-        </pc:spChg>
-        <pc:spChg chg="mod replId">
-          <ac:chgData name="Tirthankar Barari (TR)" userId="e41d4ef3-c9c5-4f08-a494-4c3cb9d953aa" providerId="ADAL" clId="{FDA9B3D4-9EE2-49C8-BD6B-D26A18FAF216}" dt="2026-06-03T19:47:53.705" v="1826" actId="26606"/>
-          <ac:spMkLst>
-            <pc:docMk/>
-            <pc:sldMk cId="0" sldId="259"/>
-            <ac:spMk id="56" creationId="{00000000-0000-0000-0000-000000000000}"/>
-          </ac:spMkLst>
-        </pc:spChg>
-        <pc:spChg chg="mod replId">
-          <ac:chgData name="Tirthankar Barari (TR)" userId="e41d4ef3-c9c5-4f08-a494-4c3cb9d953aa" providerId="ADAL" clId="{FDA9B3D4-9EE2-49C8-BD6B-D26A18FAF216}" dt="2026-06-03T19:51:46.968" v="1828" actId="26606"/>
-          <ac:spMkLst>
-            <pc:docMk/>
-            <pc:sldMk cId="0" sldId="259"/>
-            <ac:spMk id="58" creationId="{00000000-0000-0000-0000-000000000000}"/>
-          </ac:spMkLst>
-        </pc:spChg>
-        <pc:spChg chg="add mod replId">
-          <ac:chgData name="Tirthankar Barari (TR)" userId="e41d4ef3-c9c5-4f08-a494-4c3cb9d953aa" providerId="ADAL" clId="{FDA9B3D4-9EE2-49C8-BD6B-D26A18FAF216}" dt="2026-06-03T19:51:46.968" v="1828" actId="26606"/>
-          <ac:spMkLst>
-            <pc:docMk/>
-            <pc:sldMk cId="0" sldId="259"/>
-            <ac:spMk id="60" creationId="{00000000-0000-0000-0000-000000000000}"/>
-          </ac:spMkLst>
-        </pc:spChg>
-        <pc:spChg chg="mod replId">
-          <ac:chgData name="Tirthankar Barari (TR)" userId="e41d4ef3-c9c5-4f08-a494-4c3cb9d953aa" providerId="ADAL" clId="{FDA9B3D4-9EE2-49C8-BD6B-D26A18FAF216}" dt="2026-06-03T19:51:46.968" v="1828" actId="26606"/>
-          <ac:spMkLst>
-            <pc:docMk/>
-            <pc:sldMk cId="0" sldId="259"/>
-            <ac:spMk id="63" creationId="{00000000-0000-0000-0000-000000000000}"/>
-          </ac:spMkLst>
-        </pc:spChg>
-        <pc:spChg chg="add mod replId">
-          <ac:chgData name="Tirthankar Barari (TR)" userId="e41d4ef3-c9c5-4f08-a494-4c3cb9d953aa" providerId="ADAL" clId="{FDA9B3D4-9EE2-49C8-BD6B-D26A18FAF216}" dt="2026-06-03T19:51:46.968" v="1828" actId="26606"/>
-          <ac:spMkLst>
-            <pc:docMk/>
-            <pc:sldMk cId="0" sldId="259"/>
-            <ac:spMk id="65" creationId="{00000000-0000-0000-0000-000000000000}"/>
-          </ac:spMkLst>
-        </pc:spChg>
-        <pc:picChg chg="mod replId">
-          <ac:chgData name="Tirthankar Barari (TR)" userId="e41d4ef3-c9c5-4f08-a494-4c3cb9d953aa" providerId="ADAL" clId="{FDA9B3D4-9EE2-49C8-BD6B-D26A18FAF216}" dt="2026-06-03T19:47:53.705" v="1826" actId="26606"/>
-          <ac:picMkLst>
-            <pc:docMk/>
-            <pc:sldMk cId="0" sldId="259"/>
-            <ac:picMk id="44" creationId="{00000000-0000-0000-0000-000000000000}"/>
-          </ac:picMkLst>
-        </pc:picChg>
-        <pc:picChg chg="mod replId">
-          <ac:chgData name="Tirthankar Barari (TR)" userId="e41d4ef3-c9c5-4f08-a494-4c3cb9d953aa" providerId="ADAL" clId="{FDA9B3D4-9EE2-49C8-BD6B-D26A18FAF216}" dt="2026-06-03T19:47:53.705" v="1826" actId="26606"/>
-          <ac:picMkLst>
-            <pc:docMk/>
-            <pc:sldMk cId="0" sldId="259"/>
-            <ac:picMk id="46" creationId="{00000000-0000-0000-0000-000000000000}"/>
-          </ac:picMkLst>
-        </pc:picChg>
-        <pc:picChg chg="mod replId">
-          <ac:chgData name="Tirthankar Barari (TR)" userId="e41d4ef3-c9c5-4f08-a494-4c3cb9d953aa" providerId="ADAL" clId="{FDA9B3D4-9EE2-49C8-BD6B-D26A18FAF216}" dt="2026-06-03T19:51:46.968" v="1828" actId="26606"/>
-          <ac:picMkLst>
-            <pc:docMk/>
-            <pc:sldMk cId="0" sldId="259"/>
-            <ac:picMk id="51" creationId="{00000000-0000-0000-0000-000000000000}"/>
-          </ac:picMkLst>
-        </pc:picChg>
-        <pc:picChg chg="mod replId">
-          <ac:chgData name="Tirthankar Barari (TR)" userId="e41d4ef3-c9c5-4f08-a494-4c3cb9d953aa" providerId="ADAL" clId="{FDA9B3D4-9EE2-49C8-BD6B-D26A18FAF216}" dt="2026-06-03T19:51:46.968" v="1828" actId="26606"/>
-          <ac:picMkLst>
-            <pc:docMk/>
-            <pc:sldMk cId="0" sldId="259"/>
-            <ac:picMk id="55" creationId="{00000000-0000-0000-0000-000000000000}"/>
-          </ac:picMkLst>
-        </pc:picChg>
-        <pc:picChg chg="mod replId">
-          <ac:chgData name="Tirthankar Barari (TR)" userId="e41d4ef3-c9c5-4f08-a494-4c3cb9d953aa" providerId="ADAL" clId="{FDA9B3D4-9EE2-49C8-BD6B-D26A18FAF216}" dt="2026-06-03T19:51:46.968" v="1828" actId="26606"/>
-          <ac:picMkLst>
-            <pc:docMk/>
-            <pc:sldMk cId="0" sldId="259"/>
-            <ac:picMk id="61" creationId="{00000000-0000-0000-0000-000000000000}"/>
-          </ac:picMkLst>
-        </pc:picChg>
       </pc:sldChg>
-      <pc:sldChg chg="new del ord replId">
-        <pc:chgData name="Tirthankar Barari (TR)" userId="e41d4ef3-c9c5-4f08-a494-4c3cb9d953aa" providerId="ADAL" clId="{FDA9B3D4-9EE2-49C8-BD6B-D26A18FAF216}" dt="2026-06-03T19:37:00.512" v="1779" actId="26606"/>
-        <pc:sldMkLst>
-          <pc:docMk/>
-          <pc:sldMk cId="1607620579" sldId="260"/>
-        </pc:sldMkLst>
-      </pc:sldChg>
-      <pc:sldChg chg="add">
-        <pc:chgData name="Tirthankar Barari (TR)" userId="e41d4ef3-c9c5-4f08-a494-4c3cb9d953aa" providerId="ADAL" clId="{FDA9B3D4-9EE2-49C8-BD6B-D26A18FAF216}" dt="2026-06-03T21:06:35.142" v="1897" actId="2890"/>
+      <pc:sldChg chg="modSp add mod">
+        <pc:chgData name="Tirthankar Barari (TR)" userId="e41d4ef3-c9c5-4f08-a494-4c3cb9d953aa" providerId="ADAL" clId="{FDA9B3D4-9EE2-49C8-BD6B-D26A18FAF216}" dt="2026-06-25T20:02:33.610" v="2092" actId="26606"/>
         <pc:sldMkLst>
           <pc:docMk/>
           <pc:sldMk cId="4220579460" sldId="260"/>
         </pc:sldMkLst>
+        <pc:grpChg chg="add mod">
+          <ac:chgData name="Tirthankar Barari (TR)" userId="e41d4ef3-c9c5-4f08-a494-4c3cb9d953aa" providerId="ADAL" clId="{FDA9B3D4-9EE2-49C8-BD6B-D26A18FAF216}" dt="2026-06-25T20:02:33.610" v="2092" actId="26606"/>
+          <ac:grpSpMkLst>
+            <pc:docMk/>
+            <pc:sldMk cId="4220579460" sldId="260"/>
+            <ac:grpSpMk id="98" creationId="{6899C10E-A9C1-1DD7-B895-FD0AB503BEBA}"/>
+          </ac:grpSpMkLst>
+        </pc:grpChg>
+        <pc:grpChg chg="add mod">
+          <ac:chgData name="Tirthankar Barari (TR)" userId="e41d4ef3-c9c5-4f08-a494-4c3cb9d953aa" providerId="ADAL" clId="{FDA9B3D4-9EE2-49C8-BD6B-D26A18FAF216}" dt="2026-06-25T20:02:33.610" v="2092" actId="26606"/>
+          <ac:grpSpMkLst>
+            <pc:docMk/>
+            <pc:sldMk cId="4220579460" sldId="260"/>
+            <ac:grpSpMk id="99" creationId="{0E8AFD54-E035-1E10-8F67-30ABD0FFD0CE}"/>
+          </ac:grpSpMkLst>
+        </pc:grpChg>
+        <pc:grpChg chg="add mod">
+          <ac:chgData name="Tirthankar Barari (TR)" userId="e41d4ef3-c9c5-4f08-a494-4c3cb9d953aa" providerId="ADAL" clId="{FDA9B3D4-9EE2-49C8-BD6B-D26A18FAF216}" dt="2026-06-25T20:02:33.610" v="2092" actId="26606"/>
+          <ac:grpSpMkLst>
+            <pc:docMk/>
+            <pc:sldMk cId="4220579460" sldId="260"/>
+            <ac:grpSpMk id="100" creationId="{5B4560FB-9EDD-2F9E-EA7D-2FFDF347CEE4}"/>
+          </ac:grpSpMkLst>
+        </pc:grpChg>
+        <pc:grpChg chg="add mod">
+          <ac:chgData name="Tirthankar Barari (TR)" userId="e41d4ef3-c9c5-4f08-a494-4c3cb9d953aa" providerId="ADAL" clId="{FDA9B3D4-9EE2-49C8-BD6B-D26A18FAF216}" dt="2026-06-25T20:02:33.610" v="2092" actId="26606"/>
+          <ac:grpSpMkLst>
+            <pc:docMk/>
+            <pc:sldMk cId="4220579460" sldId="260"/>
+            <ac:grpSpMk id="106" creationId="{FEF7A88E-54F9-4AD7-5017-42C9DF495A31}"/>
+          </ac:grpSpMkLst>
+        </pc:grpChg>
+        <pc:grpChg chg="add mod">
+          <ac:chgData name="Tirthankar Barari (TR)" userId="e41d4ef3-c9c5-4f08-a494-4c3cb9d953aa" providerId="ADAL" clId="{FDA9B3D4-9EE2-49C8-BD6B-D26A18FAF216}" dt="2026-06-25T20:02:33.610" v="2092" actId="26606"/>
+          <ac:grpSpMkLst>
+            <pc:docMk/>
+            <pc:sldMk cId="4220579460" sldId="260"/>
+            <ac:grpSpMk id="113" creationId="{425084F3-3034-5DEC-A0B2-534B80CC13BB}"/>
+          </ac:grpSpMkLst>
+        </pc:grpChg>
+        <pc:grpChg chg="add mod">
+          <ac:chgData name="Tirthankar Barari (TR)" userId="e41d4ef3-c9c5-4f08-a494-4c3cb9d953aa" providerId="ADAL" clId="{FDA9B3D4-9EE2-49C8-BD6B-D26A18FAF216}" dt="2026-06-25T20:02:33.610" v="2092" actId="26606"/>
+          <ac:grpSpMkLst>
+            <pc:docMk/>
+            <pc:sldMk cId="4220579460" sldId="260"/>
+            <ac:grpSpMk id="137" creationId="{4B329599-2FC5-3C9E-FEC9-FA77E26DC450}"/>
+          </ac:grpSpMkLst>
+        </pc:grpChg>
+        <pc:grpChg chg="add mod">
+          <ac:chgData name="Tirthankar Barari (TR)" userId="e41d4ef3-c9c5-4f08-a494-4c3cb9d953aa" providerId="ADAL" clId="{FDA9B3D4-9EE2-49C8-BD6B-D26A18FAF216}" dt="2026-06-25T20:02:33.610" v="2092" actId="26606"/>
+          <ac:grpSpMkLst>
+            <pc:docMk/>
+            <pc:sldMk cId="4220579460" sldId="260"/>
+            <ac:grpSpMk id="138" creationId="{14CD0C07-3F4F-4A8C-9375-93B2666BDC9D}"/>
+          </ac:grpSpMkLst>
+        </pc:grpChg>
+        <pc:grpChg chg="add mod">
+          <ac:chgData name="Tirthankar Barari (TR)" userId="e41d4ef3-c9c5-4f08-a494-4c3cb9d953aa" providerId="ADAL" clId="{FDA9B3D4-9EE2-49C8-BD6B-D26A18FAF216}" dt="2026-06-25T20:02:33.610" v="2092" actId="26606"/>
+          <ac:grpSpMkLst>
+            <pc:docMk/>
+            <pc:sldMk cId="4220579460" sldId="260"/>
+            <ac:grpSpMk id="139" creationId="{98D27556-EF2C-EBBF-9BB3-8887C04E82F2}"/>
+          </ac:grpSpMkLst>
+        </pc:grpChg>
       </pc:sldChg>
-      <pc:sldChg chg="new del">
-        <pc:chgData name="Tirthankar Barari (TR)" userId="e41d4ef3-c9c5-4f08-a494-4c3cb9d953aa" providerId="ADAL" clId="{FDA9B3D4-9EE2-49C8-BD6B-D26A18FAF216}" dt="2026-06-03T21:33:32.615" v="2091" actId="2696"/>
+      <pc:sldChg chg="addSp modSp add mod ord modNotesTx">
+        <pc:chgData name="Tirthankar Barari (TR)" userId="e41d4ef3-c9c5-4f08-a494-4c3cb9d953aa" providerId="ADAL" clId="{FDA9B3D4-9EE2-49C8-BD6B-D26A18FAF216}" dt="2026-06-25T21:52:05.194" v="3287" actId="20577"/>
         <pc:sldMkLst>
           <pc:docMk/>
-          <pc:sldMk cId="3587859532" sldId="261"/>
+          <pc:sldMk cId="0" sldId="261"/>
         </pc:sldMkLst>
+        <pc:spChg chg="add mod">
+          <ac:chgData name="Tirthankar Barari (TR)" userId="e41d4ef3-c9c5-4f08-a494-4c3cb9d953aa" providerId="ADAL" clId="{FDA9B3D4-9EE2-49C8-BD6B-D26A18FAF216}" dt="2026-06-25T21:52:05.194" v="3287" actId="20577"/>
+          <ac:spMkLst>
+            <pc:docMk/>
+            <pc:sldMk cId="0" sldId="261"/>
+            <ac:spMk id="105" creationId="{00000000-0000-0000-0000-000000000000}"/>
+          </ac:spMkLst>
+        </pc:spChg>
+        <pc:graphicFrameChg chg="mod modGraphic">
+          <ac:chgData name="Tirthankar Barari (TR)" userId="e41d4ef3-c9c5-4f08-a494-4c3cb9d953aa" providerId="ADAL" clId="{FDA9B3D4-9EE2-49C8-BD6B-D26A18FAF216}" dt="2026-06-25T21:50:36.519" v="3215" actId="947"/>
+          <ac:graphicFrameMkLst>
+            <pc:docMk/>
+            <pc:sldMk cId="0" sldId="261"/>
+            <ac:graphicFrameMk id="104" creationId="{00000000-0000-0000-0000-000000000000}"/>
+          </ac:graphicFrameMkLst>
+        </pc:graphicFrameChg>
       </pc:sldChg>
     </pc:docChg>
   </pc:docChgLst>
@@ -1853,6 +1546,151 @@
   <p:cSld>
     <p:spTree>
       <p:nvGrpSpPr>
+        <p:cNvPr id="1" name=""/>
+        <p:cNvGrpSpPr/>
+        <p:nvPr/>
+      </p:nvGrpSpPr>
+      <p:grpSpPr>
+        <a:xfrm>
+          <a:off x="0" y="0"/>
+          <a:ext cx="0" cy="0"/>
+          <a:chOff x="0" y="0"/>
+          <a:chExt cx="0" cy="0"/>
+        </a:xfrm>
+      </p:grpSpPr>
+      <p:sp>
+        <p:nvSpPr>
+          <p:cNvPr id="2" name="Slide Image Placeholder 1"/>
+          <p:cNvSpPr>
+            <a:spLocks noGrp="1" noRot="1" noChangeAspect="1"/>
+          </p:cNvSpPr>
+          <p:nvPr>
+            <p:ph type="sldImg"/>
+          </p:nvPr>
+        </p:nvSpPr>
+        <p:spPr>
+          <a:xfrm>
+            <a:off x="-228600" y="1524000"/>
+            <a:ext cx="7315200" cy="4114800"/>
+          </a:xfrm>
+          <a:prstGeom prst="rect">
+            <a:avLst/>
+          </a:prstGeom>
+          <a:noFill/>
+          <a:ln w="12700">
+            <a:solidFill>
+              <a:prstClr val="black"/>
+            </a:solidFill>
+          </a:ln>
+        </p:spPr>
+      </p:sp>
+      <p:sp>
+        <p:nvSpPr>
+          <p:cNvPr id="3" name="Notes Placeholder 2"/>
+          <p:cNvSpPr>
+            <a:spLocks noGrp="1"/>
+          </p:cNvSpPr>
+          <p:nvPr>
+            <p:ph type="body" idx="1"/>
+          </p:nvPr>
+        </p:nvSpPr>
+        <p:spPr>
+          <a:xfrm>
+            <a:off x="685800" y="5867400"/>
+            <a:ext cx="5486400" cy="4800600"/>
+          </a:xfrm>
+          <a:prstGeom prst="rect">
+            <a:avLst/>
+          </a:prstGeom>
+        </p:spPr>
+        <p:txBody>
+          <a:bodyPr/>
+          <a:lstStyle/>
+          <a:p>
+            <a:pPr marL="171450" indent="-171450">
+              <a:buFont typeface="Arial" panose="020B0604020202020204" pitchFamily="34" charset="0"/>
+              <a:buChar char="•"/>
+            </a:pPr>
+            <a:r>
+              <a:rPr lang="en-US" sz="1200" b="0" i="0" kern="1200" dirty="0">
+                <a:solidFill>
+                  <a:schemeClr val="tx1"/>
+                </a:solidFill>
+                <a:effectLst/>
+                <a:latin typeface="+mn-lt"/>
+                <a:ea typeface="+mn-ea"/>
+                <a:cs typeface="+mn-cs"/>
+              </a:rPr>
+              <a:t>The default maximum message size for Microsoft mailboxes is 35 MB for sending and 36 MB for receiving. Microsoft administrators can specify a custom limit between 1 MB and 150 MB. However, the size of message you can send or receive also depends on what your email client or solution supports. For more information about customizing the maximum allowed message size for your organization, see </a:t>
+            </a:r>
+            <a:r>
+              <a:rPr lang="en-US" sz="1200" b="0" i="0" u="none" strike="noStrike" kern="1200" dirty="0">
+                <a:solidFill>
+                  <a:schemeClr val="tx1"/>
+                </a:solidFill>
+                <a:effectLst/>
+                <a:latin typeface="+mn-lt"/>
+                <a:ea typeface="+mn-ea"/>
+                <a:cs typeface="+mn-cs"/>
+                <a:hlinkClick r:id="rId3"/>
+              </a:rPr>
+              <a:t>Microsoft supports larger email messages</a:t>
+            </a:r>
+            <a:r>
+              <a:rPr lang="en-US" sz="1200" b="0" i="0" kern="1200" dirty="0">
+                <a:solidFill>
+                  <a:schemeClr val="tx1"/>
+                </a:solidFill>
+                <a:effectLst/>
+                <a:latin typeface="+mn-lt"/>
+                <a:ea typeface="+mn-ea"/>
+                <a:cs typeface="+mn-cs"/>
+              </a:rPr>
+              <a:t>.</a:t>
+            </a:r>
+          </a:p>
+          <a:p>
+            <a:pPr marL="171450" indent="-171450">
+              <a:buFont typeface="Arial" panose="020B0604020202020204" pitchFamily="34" charset="0"/>
+              <a:buChar char="•"/>
+            </a:pPr>
+            <a:r>
+              <a:rPr lang="en-US" sz="1200" b="0" i="0" kern="1200" dirty="0">
+                <a:solidFill>
+                  <a:schemeClr val="tx1"/>
+                </a:solidFill>
+                <a:effectLst/>
+                <a:latin typeface="+mn-lt"/>
+                <a:ea typeface="+mn-ea"/>
+                <a:cs typeface="+mn-cs"/>
+              </a:rPr>
+              <a:t>You can send and receive up to 150 MB messages between users (where the message never leaves the Microsoft datacenters). Messages that are routed outside of the Microsoft datacenters are subject to an additional 33% translation encoding increase, in which case the maximum message size is 112 MB.</a:t>
+            </a:r>
+            <a:br>
+              <a:rPr lang="en-US" dirty="0"/>
+            </a:br>
+            <a:endParaRPr lang="en-US" dirty="0"/>
+          </a:p>
+        </p:txBody>
+      </p:sp>
+    </p:spTree>
+    <p:extLst>
+      <p:ext uri="{BB962C8B-B14F-4D97-AF65-F5344CB8AC3E}">
+        <p14:creationId xmlns:p14="http://schemas.microsoft.com/office/powerpoint/2010/main" val="2353168845"/>
+      </p:ext>
+    </p:extLst>
+  </p:cSld>
+  <p:clrMapOvr>
+    <a:masterClrMapping/>
+  </p:clrMapOvr>
+</p:notes>
+</file>
+
+<file path=ppt/notesSlides/notesSlide3.xml><?xml version="1.0" encoding="utf-8"?>
+<p:notes xmlns:a="http://schemas.openxmlformats.org/drawingml/2006/main" xmlns:r="http://schemas.openxmlformats.org/officeDocument/2006/relationships" xmlns:p="http://schemas.openxmlformats.org/presentationml/2006/main">
+  <p:cSld>
+    <p:spTree>
+      <p:nvGrpSpPr>
         <p:cNvPr id="1" name="">
           <a:extLst>
             <a:ext uri="{FF2B5EF4-FFF2-40B4-BE49-F238E27FC236}">
@@ -1944,7 +1782,7 @@
           <a:p>
             <a:fld id="{F7021451-1387-4CA6-816F-3879F97B5CBC}" type="slidenum">
               <a:rPr lang="en-US"/>
-              <a:t>3</a:t>
+              <a:t>4</a:t>
             </a:fld>
             <a:endParaRPr lang="en-US"/>
           </a:p>
@@ -4956,8 +4794,8 @@
           </p:blipFill>
           <p:spPr>
             <a:xfrm>
-              <a:off x="603504" y="1563624"/>
-              <a:ext cx="274320" cy="274320"/>
+              <a:off x="624132" y="1563624"/>
+              <a:ext cx="233064" cy="274320"/>
             </a:xfrm>
             <a:prstGeom prst="rect">
               <a:avLst/>
@@ -5156,8 +4994,8 @@
           </p:blipFill>
           <p:spPr>
             <a:xfrm>
-              <a:off x="603504" y="2432304"/>
-              <a:ext cx="274320" cy="274320"/>
+              <a:off x="624132" y="2432304"/>
+              <a:ext cx="233064" cy="274320"/>
             </a:xfrm>
             <a:prstGeom prst="rect">
               <a:avLst/>
@@ -5242,7 +5080,7 @@
                 <a:buChar char="•"/>
               </a:pPr>
               <a:r>
-                <a:rPr lang="en-US" sz="1000" dirty="0">
+                <a:rPr lang="en-US" sz="1000">
                   <a:solidFill>
                     <a:srgbClr val="8899AA"/>
                   </a:solidFill>
@@ -5252,7 +5090,7 @@
                 </a:rPr>
                 <a:t>Coordinates extraction pipeline</a:t>
               </a:r>
-              <a:endParaRPr lang="en-US" sz="1000" dirty="0"/>
+              <a:endParaRPr lang="en-US" sz="1000"/>
             </a:p>
           </p:txBody>
         </p:sp>
@@ -5339,8 +5177,8 @@
           </p:blipFill>
           <p:spPr>
             <a:xfrm>
-              <a:off x="603504" y="3300984"/>
-              <a:ext cx="274320" cy="274320"/>
+              <a:off x="624132" y="3300984"/>
+              <a:ext cx="233064" cy="274320"/>
             </a:xfrm>
             <a:prstGeom prst="rect">
               <a:avLst/>
@@ -7855,8 +7693,8 @@
           </p:blipFill>
           <p:spPr>
             <a:xfrm>
-              <a:off x="5900798" y="3035808"/>
-              <a:ext cx="274320" cy="274320"/>
+              <a:off x="5919550" y="3035808"/>
+              <a:ext cx="236815" cy="274320"/>
             </a:xfrm>
             <a:prstGeom prst="rect">
               <a:avLst/>
@@ -7952,8 +7790,8 @@
           </p:blipFill>
           <p:spPr>
             <a:xfrm>
-              <a:off x="570936" y="1593154"/>
-              <a:ext cx="255059" cy="274320"/>
+              <a:off x="570936" y="1602784"/>
+              <a:ext cx="255059" cy="255059"/>
             </a:xfrm>
             <a:prstGeom prst="rect">
               <a:avLst/>
@@ -8038,7 +7876,7 @@
                 <a:buChar char="•"/>
               </a:pPr>
               <a:r>
-                <a:rPr lang="en-US" sz="1000" dirty="0">
+                <a:rPr lang="en-US" sz="1000">
                   <a:solidFill>
                     <a:srgbClr val="8899AA"/>
                   </a:solidFill>
@@ -8055,7 +7893,7 @@
                 <a:buChar char="•"/>
               </a:pPr>
               <a:r>
-                <a:rPr lang="en-US" sz="1000" dirty="0">
+                <a:rPr lang="en-US" sz="1000">
                   <a:solidFill>
                     <a:srgbClr val="8899AA"/>
                   </a:solidFill>
@@ -8065,7 +7903,7 @@
                 </a:rPr>
                 <a:t>Access via MS Graph API</a:t>
               </a:r>
-              <a:endParaRPr lang="en-US" sz="1000" dirty="0">
+              <a:endParaRPr lang="en-US" sz="1000">
                 <a:solidFill>
                   <a:srgbClr val="8899AA"/>
                 </a:solidFill>
@@ -8080,7 +7918,7 @@
                 <a:buChar char="•"/>
               </a:pPr>
               <a:r>
-                <a:rPr lang="en-US" sz="1000" dirty="0">
+                <a:rPr lang="en-US" sz="1000">
                   <a:solidFill>
                     <a:srgbClr val="8899AA"/>
                   </a:solidFill>
@@ -8090,7 +7928,7 @@
                 </a:rPr>
                 <a:t>Secured access</a:t>
               </a:r>
-              <a:endParaRPr lang="en-US" sz="1000" dirty="0">
+              <a:endParaRPr lang="en-US" sz="1000">
                 <a:solidFill>
                   <a:srgbClr val="8899AA"/>
                 </a:solidFill>
@@ -8395,8 +8233,8 @@
           </p:blipFill>
           <p:spPr>
             <a:xfrm>
-              <a:off x="2307502" y="4169477"/>
-              <a:ext cx="187457" cy="201612"/>
+              <a:off x="2307502" y="4176554"/>
+              <a:ext cx="187457" cy="187457"/>
             </a:xfrm>
             <a:prstGeom prst="rect">
               <a:avLst/>
@@ -8735,8 +8573,8 @@
           </p:blipFill>
           <p:spPr>
             <a:xfrm>
-              <a:off x="419149" y="4169477"/>
-              <a:ext cx="187457" cy="201613"/>
+              <a:off x="419149" y="4176555"/>
+              <a:ext cx="187457" cy="187457"/>
             </a:xfrm>
             <a:prstGeom prst="rect">
               <a:avLst/>
@@ -8930,8 +8768,8 @@
           </p:blipFill>
           <p:spPr>
             <a:xfrm>
-              <a:off x="4153701" y="4169477"/>
-              <a:ext cx="187457" cy="206588"/>
+              <a:off x="4153701" y="4179042"/>
+              <a:ext cx="187457" cy="187457"/>
             </a:xfrm>
             <a:prstGeom prst="rect">
               <a:avLst/>
@@ -9124,6 +8962,908 @@
   <p:cSld>
     <p:bg>
       <p:bgPr>
+        <a:blipFill dpi="0" rotWithShape="1">
+          <a:blip r:embed="rId3">
+            <a:lum/>
+          </a:blip>
+          <a:srcRect/>
+          <a:stretch>
+            <a:fillRect/>
+          </a:stretch>
+        </a:blipFill>
+        <a:effectLst/>
+      </p:bgPr>
+    </p:bg>
+    <p:spTree>
+      <p:nvGrpSpPr>
+        <p:cNvPr id="1" name=""/>
+        <p:cNvGrpSpPr/>
+        <p:nvPr/>
+      </p:nvGrpSpPr>
+      <p:grpSpPr>
+        <a:xfrm>
+          <a:off x="0" y="0"/>
+          <a:ext cx="0" cy="0"/>
+          <a:chOff x="0" y="0"/>
+          <a:chExt cx="0" cy="0"/>
+        </a:xfrm>
+      </p:grpSpPr>
+      <p:sp>
+        <p:nvSpPr>
+          <p:cNvPr id="101" name="Accent Bar">
+            <a:extLst>
+              <a:ext uri="{C183D7F6-B498-43B3-948B-1728B52AA6E4}">
+                <adec:decorative xmlns:adec="http://schemas.microsoft.com/office/drawing/2017/decorative" val="1"/>
+              </a:ext>
+            </a:extLst>
+          </p:cNvPr>
+          <p:cNvSpPr/>
+          <p:nvPr/>
+        </p:nvSpPr>
+        <p:spPr>
+          <a:xfrm>
+            <a:off x="731520" y="457200"/>
+            <a:ext cx="914400" cy="32004"/>
+          </a:xfrm>
+          <a:prstGeom prst="rect">
+            <a:avLst/>
+          </a:prstGeom>
+          <a:solidFill>
+            <a:srgbClr val="D4A843"/>
+          </a:solidFill>
+        </p:spPr>
+        <p:txBody>
+          <a:bodyPr/>
+          <a:lstStyle/>
+          <a:p>
+            <a:endParaRPr/>
+          </a:p>
+        </p:txBody>
+      </p:sp>
+      <p:sp>
+        <p:nvSpPr>
+          <p:cNvPr id="102" name="Title"/>
+          <p:cNvSpPr/>
+          <p:nvPr/>
+        </p:nvSpPr>
+        <p:spPr>
+          <a:xfrm>
+            <a:off x="731520" y="594360"/>
+            <a:ext cx="10728960" cy="548640"/>
+          </a:xfrm>
+          <a:prstGeom prst="rect">
+            <a:avLst/>
+          </a:prstGeom>
+        </p:spPr>
+        <p:txBody>
+          <a:bodyPr/>
+          <a:lstStyle/>
+          <a:p>
+            <a:r>
+              <a:rPr lang="en-US" sz="3000" b="1" kern="0" spc="300">
+                <a:solidFill>
+                  <a:srgbClr val="FFFFFF"/>
+                </a:solidFill>
+              </a:rPr>
+              <a:t>Service Limits &amp; Quotas</a:t>
+            </a:r>
+          </a:p>
+        </p:txBody>
+      </p:sp>
+      <p:sp>
+        <p:nvSpPr>
+          <p:cNvPr id="103" name="Subtitle"/>
+          <p:cNvSpPr/>
+          <p:nvPr/>
+        </p:nvSpPr>
+        <p:spPr>
+          <a:xfrm>
+            <a:off x="731520" y="1124712"/>
+            <a:ext cx="10728960" cy="320040"/>
+          </a:xfrm>
+          <a:prstGeom prst="rect">
+            <a:avLst/>
+          </a:prstGeom>
+        </p:spPr>
+        <p:txBody>
+          <a:bodyPr/>
+          <a:lstStyle/>
+          <a:p>
+            <a:r>
+              <a:rPr lang="en-US" sz="1400" i="1">
+                <a:solidFill>
+                  <a:srgbClr val="8899AA"/>
+                </a:solidFill>
+              </a:rPr>
+              <a:t>Rate Limits and Size Constraints</a:t>
+            </a:r>
+          </a:p>
+        </p:txBody>
+      </p:sp>
+      <p:graphicFrame>
+        <p:nvGraphicFramePr>
+          <p:cNvPr id="104" name="Service Limits Table" descr="Table comparing API call rate limits, maximum attachment or file size, and maximum message size across Microsoft Graph Mailbox, Azure Content Understanding, and Microsoft 365 Exchange Online Mailbox."/>
+          <p:cNvGraphicFramePr>
+            <a:graphicFrameLocks noGrp="1"/>
+          </p:cNvGraphicFramePr>
+          <p:nvPr>
+            <p:extLst>
+              <p:ext uri="{D42A27DB-BD31-4B8C-83A1-F6EECF244321}">
+                <p14:modId xmlns:p14="http://schemas.microsoft.com/office/powerpoint/2010/main" val="397214872"/>
+              </p:ext>
+            </p:extLst>
+          </p:nvPr>
+        </p:nvGraphicFramePr>
+        <p:xfrm>
+          <a:off x="731520" y="1755648"/>
+          <a:ext cx="10728960" cy="2800000"/>
+        </p:xfrm>
+        <a:graphic>
+          <a:graphicData uri="http://schemas.openxmlformats.org/drawingml/2006/table">
+            <a:tbl>
+              <a:tblPr firstRow="1" bandRow="1">
+                <a:tableStyleId>{5C22544A-7EE6-4342-B048-85BDC9FD1C3A}</a:tableStyleId>
+              </a:tblPr>
+              <a:tblGrid>
+                <a:gridCol w="3600000">
+                  <a:extLst>
+                    <a:ext uri="{9D8B030D-6E8A-4147-A177-3AD203B41FA5}">
+                      <a16:colId xmlns:a16="http://schemas.microsoft.com/office/drawing/2014/main" val="20000"/>
+                    </a:ext>
+                  </a:extLst>
+                </a:gridCol>
+                <a:gridCol w="2400000">
+                  <a:extLst>
+                    <a:ext uri="{9D8B030D-6E8A-4147-A177-3AD203B41FA5}">
+                      <a16:colId xmlns:a16="http://schemas.microsoft.com/office/drawing/2014/main" val="20001"/>
+                    </a:ext>
+                  </a:extLst>
+                </a:gridCol>
+                <a:gridCol w="2400000">
+                  <a:extLst>
+                    <a:ext uri="{9D8B030D-6E8A-4147-A177-3AD203B41FA5}">
+                      <a16:colId xmlns:a16="http://schemas.microsoft.com/office/drawing/2014/main" val="20002"/>
+                    </a:ext>
+                  </a:extLst>
+                </a:gridCol>
+                <a:gridCol w="2328960">
+                  <a:extLst>
+                    <a:ext uri="{9D8B030D-6E8A-4147-A177-3AD203B41FA5}">
+                      <a16:colId xmlns:a16="http://schemas.microsoft.com/office/drawing/2014/main" val="20003"/>
+                    </a:ext>
+                  </a:extLst>
+                </a:gridCol>
+              </a:tblGrid>
+              <a:tr h="520000">
+                <a:tc>
+                  <a:txBody>
+                    <a:bodyPr/>
+                    <a:lstStyle/>
+                    <a:p>
+                      <a:r>
+                        <a:rPr lang="en-US" sz="1200" b="1">
+                          <a:solidFill>
+                            <a:srgbClr val="FFFFFF"/>
+                          </a:solidFill>
+                        </a:rPr>
+                        <a:t>Service</a:t>
+                      </a:r>
+                    </a:p>
+                  </a:txBody>
+                  <a:tcPr marL="109728" marR="109728" marT="54864" marB="54864" anchor="ctr">
+                    <a:solidFill>
+                      <a:srgbClr val="E76F51"/>
+                    </a:solidFill>
+                  </a:tcPr>
+                </a:tc>
+                <a:tc>
+                  <a:txBody>
+                    <a:bodyPr/>
+                    <a:lstStyle/>
+                    <a:p>
+                      <a:r>
+                        <a:rPr lang="en-US" sz="1200" b="1">
+                          <a:solidFill>
+                            <a:srgbClr val="FFFFFF"/>
+                          </a:solidFill>
+                        </a:rPr>
+                        <a:t>API Calls / Hour</a:t>
+                      </a:r>
+                    </a:p>
+                  </a:txBody>
+                  <a:tcPr marL="109728" marR="109728" marT="54864" marB="54864" anchor="ctr">
+                    <a:solidFill>
+                      <a:srgbClr val="E76F51"/>
+                    </a:solidFill>
+                  </a:tcPr>
+                </a:tc>
+                <a:tc>
+                  <a:txBody>
+                    <a:bodyPr/>
+                    <a:lstStyle/>
+                    <a:p>
+                      <a:r>
+                        <a:rPr lang="en-US" sz="1200" b="1">
+                          <a:solidFill>
+                            <a:srgbClr val="FFFFFF"/>
+                          </a:solidFill>
+                        </a:rPr>
+                        <a:t>Max Attachment/File Size</a:t>
+                      </a:r>
+                    </a:p>
+                  </a:txBody>
+                  <a:tcPr marL="109728" marR="109728" marT="54864" marB="54864" anchor="ctr">
+                    <a:solidFill>
+                      <a:srgbClr val="E76F51"/>
+                    </a:solidFill>
+                  </a:tcPr>
+                </a:tc>
+                <a:tc>
+                  <a:txBody>
+                    <a:bodyPr/>
+                    <a:lstStyle/>
+                    <a:p>
+                      <a:r>
+                        <a:rPr lang="en-US" sz="1200" b="1">
+                          <a:solidFill>
+                            <a:srgbClr val="FFFFFF"/>
+                          </a:solidFill>
+                        </a:rPr>
+                        <a:t>Max Message Size</a:t>
+                      </a:r>
+                    </a:p>
+                  </a:txBody>
+                  <a:tcPr marL="109728" marR="109728" marT="54864" marB="54864" anchor="ctr">
+                    <a:solidFill>
+                      <a:srgbClr val="E76F51"/>
+                    </a:solidFill>
+                  </a:tcPr>
+                </a:tc>
+                <a:extLst>
+                  <a:ext uri="{0D108BD9-81ED-4DB2-BD59-A6C34878D82A}">
+                    <a16:rowId xmlns:a16="http://schemas.microsoft.com/office/drawing/2014/main" val="10000"/>
+                  </a:ext>
+                </a:extLst>
+              </a:tr>
+              <a:tr h="760000">
+                <a:tc>
+                  <a:txBody>
+                    <a:bodyPr/>
+                    <a:lstStyle/>
+                    <a:p>
+                      <a:r>
+                        <a:rPr lang="en-US" sz="1100" b="1">
+                          <a:solidFill>
+                            <a:srgbClr val="E8ECF0"/>
+                          </a:solidFill>
+                        </a:rPr>
+                        <a:t>Microsoft Graph (Mailbox)</a:t>
+                      </a:r>
+                    </a:p>
+                  </a:txBody>
+                  <a:tcPr marL="109728" marR="109728" marT="54864" marB="54864" anchor="ctr">
+                    <a:solidFill>
+                      <a:srgbClr val="1B2A3D"/>
+                    </a:solidFill>
+                  </a:tcPr>
+                </a:tc>
+                <a:tc>
+                  <a:txBody>
+                    <a:bodyPr/>
+                    <a:lstStyle/>
+                    <a:p>
+                      <a:r>
+                        <a:rPr lang="en-US" sz="1100" dirty="0">
+                          <a:solidFill>
+                            <a:srgbClr val="E8ECF0"/>
+                          </a:solidFill>
+                        </a:rPr>
+                        <a:t>~60,000 requests/hour per App + Mailbox </a:t>
+                      </a:r>
+                      <a:r>
+                        <a:rPr lang="en-US" sz="1100" baseline="30000" dirty="0">
+                          <a:solidFill>
+                            <a:srgbClr val="E8ECF0"/>
+                          </a:solidFill>
+                        </a:rPr>
+                        <a:t>[1]</a:t>
+                      </a:r>
+                    </a:p>
+                  </a:txBody>
+                  <a:tcPr marL="109728" marR="109728" marT="54864" marB="54864" anchor="ctr">
+                    <a:solidFill>
+                      <a:srgbClr val="1B2A3D"/>
+                    </a:solidFill>
+                  </a:tcPr>
+                </a:tc>
+                <a:tc>
+                  <a:txBody>
+                    <a:bodyPr/>
+                    <a:lstStyle/>
+                    <a:p>
+                      <a:r>
+                        <a:rPr lang="en-US" sz="1100" dirty="0">
+                          <a:solidFill>
+                            <a:srgbClr val="E8ECF0"/>
+                          </a:solidFill>
+                        </a:rPr>
+                        <a:t>150 MB </a:t>
+                      </a:r>
+                      <a:r>
+                        <a:rPr lang="en-US" sz="1100" baseline="30000" dirty="0">
+                          <a:solidFill>
+                            <a:srgbClr val="E8ECF0"/>
+                          </a:solidFill>
+                        </a:rPr>
+                        <a:t>[2]</a:t>
+                      </a:r>
+                      <a:endParaRPr lang="en-US" sz="1100" dirty="0">
+                        <a:solidFill>
+                          <a:srgbClr val="E8ECF0"/>
+                        </a:solidFill>
+                      </a:endParaRPr>
+                    </a:p>
+                  </a:txBody>
+                  <a:tcPr marL="109728" marR="109728" marT="54864" marB="54864" anchor="ctr">
+                    <a:solidFill>
+                      <a:srgbClr val="1B2A3D"/>
+                    </a:solidFill>
+                  </a:tcPr>
+                </a:tc>
+                <a:tc>
+                  <a:txBody>
+                    <a:bodyPr/>
+                    <a:lstStyle/>
+                    <a:p>
+                      <a:r>
+                        <a:rPr lang="en-US" sz="1100">
+                          <a:solidFill>
+                            <a:srgbClr val="E8ECF0"/>
+                          </a:solidFill>
+                        </a:rPr>
+                        <a:t>Exchange limit applies (150 MB)</a:t>
+                      </a:r>
+                    </a:p>
+                  </a:txBody>
+                  <a:tcPr marL="109728" marR="109728" marT="54864" marB="54864" anchor="ctr">
+                    <a:solidFill>
+                      <a:srgbClr val="1B2A3D"/>
+                    </a:solidFill>
+                  </a:tcPr>
+                </a:tc>
+                <a:extLst>
+                  <a:ext uri="{0D108BD9-81ED-4DB2-BD59-A6C34878D82A}">
+                    <a16:rowId xmlns:a16="http://schemas.microsoft.com/office/drawing/2014/main" val="10001"/>
+                  </a:ext>
+                </a:extLst>
+              </a:tr>
+              <a:tr h="760000">
+                <a:tc>
+                  <a:txBody>
+                    <a:bodyPr/>
+                    <a:lstStyle/>
+                    <a:p>
+                      <a:r>
+                        <a:rPr lang="en-US" sz="1100" b="1">
+                          <a:solidFill>
+                            <a:srgbClr val="E8ECF0"/>
+                          </a:solidFill>
+                        </a:rPr>
+                        <a:t>Azure Content Understanding</a:t>
+                      </a:r>
+                    </a:p>
+                  </a:txBody>
+                  <a:tcPr marL="109728" marR="109728" marT="54864" marB="54864" anchor="ctr">
+                    <a:solidFill>
+                      <a:srgbClr val="26384F"/>
+                    </a:solidFill>
+                  </a:tcPr>
+                </a:tc>
+                <a:tc>
+                  <a:txBody>
+                    <a:bodyPr/>
+                    <a:lstStyle/>
+                    <a:p>
+                      <a:r>
+                        <a:rPr lang="en-US" sz="1100" dirty="0">
+                          <a:solidFill>
+                            <a:srgbClr val="E8ECF0"/>
+                          </a:solidFill>
+                        </a:rPr>
+                        <a:t>180,000 operations/hour </a:t>
+                      </a:r>
+                      <a:r>
+                        <a:rPr lang="en-US" sz="1100" strike="noStrike" baseline="30000" dirty="0">
+                          <a:solidFill>
+                            <a:srgbClr val="E8ECF0"/>
+                          </a:solidFill>
+                        </a:rPr>
+                        <a:t>[3]</a:t>
+                      </a:r>
+                    </a:p>
+                  </a:txBody>
+                  <a:tcPr marL="109728" marR="109728" marT="54864" marB="54864" anchor="ctr">
+                    <a:solidFill>
+                      <a:srgbClr val="26384F"/>
+                    </a:solidFill>
+                  </a:tcPr>
+                </a:tc>
+                <a:tc>
+                  <a:txBody>
+                    <a:bodyPr/>
+                    <a:lstStyle/>
+                    <a:p>
+                      <a:r>
+                        <a:rPr lang="en-US" sz="1100" dirty="0">
+                          <a:solidFill>
+                            <a:srgbClr val="E8ECF0"/>
+                          </a:solidFill>
+                        </a:rPr>
+                        <a:t>200 MB </a:t>
+                      </a:r>
+                      <a:r>
+                        <a:rPr lang="en-US" sz="1100" baseline="30000" dirty="0">
+                          <a:solidFill>
+                            <a:srgbClr val="E8ECF0"/>
+                          </a:solidFill>
+                        </a:rPr>
+                        <a:t>[4]</a:t>
+                      </a:r>
+                    </a:p>
+                  </a:txBody>
+                  <a:tcPr marL="109728" marR="109728" marT="54864" marB="54864" anchor="ctr">
+                    <a:solidFill>
+                      <a:srgbClr val="26384F"/>
+                    </a:solidFill>
+                  </a:tcPr>
+                </a:tc>
+                <a:tc>
+                  <a:txBody>
+                    <a:bodyPr/>
+                    <a:lstStyle/>
+                    <a:p>
+                      <a:r>
+                        <a:rPr lang="en-US" sz="1100">
+                          <a:solidFill>
+                            <a:srgbClr val="E8ECF0"/>
+                          </a:solidFill>
+                        </a:rPr>
+                        <a:t>N/A</a:t>
+                      </a:r>
+                    </a:p>
+                  </a:txBody>
+                  <a:tcPr marL="109728" marR="109728" marT="54864" marB="54864" anchor="ctr">
+                    <a:solidFill>
+                      <a:srgbClr val="26384F"/>
+                    </a:solidFill>
+                  </a:tcPr>
+                </a:tc>
+                <a:extLst>
+                  <a:ext uri="{0D108BD9-81ED-4DB2-BD59-A6C34878D82A}">
+                    <a16:rowId xmlns:a16="http://schemas.microsoft.com/office/drawing/2014/main" val="10002"/>
+                  </a:ext>
+                </a:extLst>
+              </a:tr>
+              <a:tr h="760000">
+                <a:tc>
+                  <a:txBody>
+                    <a:bodyPr/>
+                    <a:lstStyle/>
+                    <a:p>
+                      <a:r>
+                        <a:rPr lang="en-US" sz="1100" b="1">
+                          <a:solidFill>
+                            <a:srgbClr val="E8ECF0"/>
+                          </a:solidFill>
+                        </a:rPr>
+                        <a:t>Microsoft 365 Exchange Online Mailbox</a:t>
+                      </a:r>
+                    </a:p>
+                  </a:txBody>
+                  <a:tcPr marL="109728" marR="109728" marT="54864" marB="54864" anchor="ctr">
+                    <a:solidFill>
+                      <a:srgbClr val="1B2A3D"/>
+                    </a:solidFill>
+                  </a:tcPr>
+                </a:tc>
+                <a:tc>
+                  <a:txBody>
+                    <a:bodyPr/>
+                    <a:lstStyle/>
+                    <a:p>
+                      <a:r>
+                        <a:rPr lang="en-US" sz="1100" dirty="0">
+                          <a:solidFill>
+                            <a:srgbClr val="E8ECF0"/>
+                          </a:solidFill>
+                        </a:rPr>
+                        <a:t>3,600 received emails/hour </a:t>
+                      </a:r>
+                      <a:r>
+                        <a:rPr lang="en-US" sz="1100" baseline="30000" dirty="0">
+                          <a:solidFill>
+                            <a:srgbClr val="E8ECF0"/>
+                          </a:solidFill>
+                        </a:rPr>
+                        <a:t>[5]</a:t>
+                      </a:r>
+                    </a:p>
+                  </a:txBody>
+                  <a:tcPr marL="109728" marR="109728" marT="54864" marB="54864" anchor="ctr">
+                    <a:solidFill>
+                      <a:srgbClr val="1B2A3D"/>
+                    </a:solidFill>
+                  </a:tcPr>
+                </a:tc>
+                <a:tc>
+                  <a:txBody>
+                    <a:bodyPr/>
+                    <a:lstStyle/>
+                    <a:p>
+                      <a:r>
+                        <a:rPr lang="en-US" sz="1100" dirty="0">
+                          <a:solidFill>
+                            <a:srgbClr val="E8ECF0"/>
+                          </a:solidFill>
+                        </a:rPr>
+                        <a:t>150 MB attachment </a:t>
+                      </a:r>
+                      <a:r>
+                        <a:rPr lang="en-US" sz="1100" baseline="30000" dirty="0">
+                          <a:solidFill>
+                            <a:srgbClr val="E8ECF0"/>
+                          </a:solidFill>
+                        </a:rPr>
+                        <a:t>[6]</a:t>
+                      </a:r>
+                    </a:p>
+                  </a:txBody>
+                  <a:tcPr marL="109728" marR="109728" marT="54864" marB="54864" anchor="ctr">
+                    <a:solidFill>
+                      <a:srgbClr val="1B2A3D"/>
+                    </a:solidFill>
+                  </a:tcPr>
+                </a:tc>
+                <a:tc>
+                  <a:txBody>
+                    <a:bodyPr/>
+                    <a:lstStyle/>
+                    <a:p>
+                      <a:r>
+                        <a:rPr lang="en-US" sz="1100" dirty="0">
+                          <a:solidFill>
+                            <a:srgbClr val="E8ECF0"/>
+                          </a:solidFill>
+                        </a:rPr>
+                        <a:t>150 MB total message [6]</a:t>
+                      </a:r>
+                    </a:p>
+                  </a:txBody>
+                  <a:tcPr marL="109728" marR="109728" marT="54864" marB="54864" anchor="ctr">
+                    <a:solidFill>
+                      <a:srgbClr val="1B2A3D"/>
+                    </a:solidFill>
+                  </a:tcPr>
+                </a:tc>
+                <a:extLst>
+                  <a:ext uri="{0D108BD9-81ED-4DB2-BD59-A6C34878D82A}">
+                    <a16:rowId xmlns:a16="http://schemas.microsoft.com/office/drawing/2014/main" val="10003"/>
+                  </a:ext>
+                </a:extLst>
+              </a:tr>
+            </a:tbl>
+          </a:graphicData>
+        </a:graphic>
+      </p:graphicFrame>
+      <p:sp>
+        <p:nvSpPr>
+          <p:cNvPr id="105" name="Reference 1"/>
+          <p:cNvSpPr txBox="1"/>
+          <p:nvPr/>
+        </p:nvSpPr>
+        <p:spPr>
+          <a:xfrm>
+            <a:off x="731520" y="4709160"/>
+            <a:ext cx="10728960" cy="1938992"/>
+          </a:xfrm>
+          <a:prstGeom prst="rect">
+            <a:avLst/>
+          </a:prstGeom>
+        </p:spPr>
+        <p:txBody>
+          <a:bodyPr wrap="square" rtlCol="0">
+            <a:spAutoFit/>
+          </a:bodyPr>
+          <a:lstStyle/>
+          <a:p>
+            <a:pPr marL="171450" indent="-171450">
+              <a:buFont typeface="Courier New" panose="02070309020205020404" pitchFamily="49" charset="0"/>
+              <a:buChar char="o"/>
+            </a:pPr>
+            <a:r>
+              <a:rPr lang="en-US" sz="1000" dirty="0">
+                <a:solidFill>
+                  <a:srgbClr val="8899AA"/>
+                </a:solidFill>
+              </a:rPr>
+              <a:t>[1] </a:t>
+            </a:r>
+            <a:r>
+              <a:rPr lang="en-US" sz="1000" dirty="0">
+                <a:solidFill>
+                  <a:srgbClr val="8899AA"/>
+                </a:solidFill>
+                <a:hlinkClick r:id="rId4"/>
+              </a:rPr>
+              <a:t>Outlook Service limit </a:t>
+            </a:r>
+            <a:r>
+              <a:rPr lang="en-US" sz="1000" dirty="0">
+                <a:solidFill>
+                  <a:srgbClr val="8899AA"/>
+                </a:solidFill>
+              </a:rPr>
+              <a:t>in Microsoft Graph API </a:t>
+            </a:r>
+          </a:p>
+          <a:p>
+            <a:pPr marL="171450" indent="-171450">
+              <a:buFont typeface="Courier New" panose="02070309020205020404" pitchFamily="49" charset="0"/>
+              <a:buChar char="o"/>
+            </a:pPr>
+            <a:endParaRPr lang="en-US" sz="1000" dirty="0">
+              <a:solidFill>
+                <a:srgbClr val="8899AA"/>
+              </a:solidFill>
+            </a:endParaRPr>
+          </a:p>
+          <a:p>
+            <a:pPr marL="171450" indent="-171450">
+              <a:buFont typeface="Courier New" panose="02070309020205020404" pitchFamily="49" charset="0"/>
+              <a:buChar char="o"/>
+            </a:pPr>
+            <a:r>
+              <a:rPr lang="en-US" sz="1000" dirty="0">
+                <a:solidFill>
+                  <a:srgbClr val="8899AA"/>
+                </a:solidFill>
+              </a:rPr>
+              <a:t>[2] Getting an attachment is not technically limited by attachment size, many factors in your infrastructure determines this size. The </a:t>
+            </a:r>
+            <a:r>
+              <a:rPr lang="en-US" sz="1000" dirty="0">
+                <a:solidFill>
+                  <a:srgbClr val="8899AA"/>
+                </a:solidFill>
+                <a:hlinkClick r:id="rId5"/>
+              </a:rPr>
+              <a:t>150 MB is the limit for uploading an attachment to an email in a mailbox, using Graph API</a:t>
+            </a:r>
+            <a:r>
+              <a:rPr lang="en-US" sz="1000" dirty="0">
+                <a:solidFill>
+                  <a:srgbClr val="8899AA"/>
+                </a:solidFill>
+              </a:rPr>
+              <a:t>. Also check </a:t>
+            </a:r>
+            <a:r>
+              <a:rPr lang="en-US" sz="1000" dirty="0">
+                <a:solidFill>
+                  <a:srgbClr val="8899AA"/>
+                </a:solidFill>
+                <a:hlinkClick r:id="rId6"/>
+              </a:rPr>
+              <a:t>Microsoft 365 message limits</a:t>
+            </a:r>
+            <a:r>
+              <a:rPr lang="en-US" sz="1000" dirty="0">
+                <a:solidFill>
+                  <a:srgbClr val="8899AA"/>
+                </a:solidFill>
+              </a:rPr>
+              <a:t>. </a:t>
+            </a:r>
+          </a:p>
+          <a:p>
+            <a:pPr marL="171450" indent="-171450">
+              <a:buFont typeface="Courier New" panose="02070309020205020404" pitchFamily="49" charset="0"/>
+              <a:buChar char="o"/>
+            </a:pPr>
+            <a:endParaRPr lang="en-US" sz="1000" dirty="0">
+              <a:solidFill>
+                <a:srgbClr val="8899AA"/>
+              </a:solidFill>
+            </a:endParaRPr>
+          </a:p>
+          <a:p>
+            <a:pPr marL="171450" indent="-171450">
+              <a:buFont typeface="Courier New" panose="02070309020205020404" pitchFamily="49" charset="0"/>
+              <a:buChar char="o"/>
+            </a:pPr>
+            <a:r>
+              <a:rPr lang="en-US" sz="1000" dirty="0">
+                <a:solidFill>
+                  <a:srgbClr val="8899AA"/>
+                </a:solidFill>
+              </a:rPr>
+              <a:t>[3] Max Azure Content Understanding Service </a:t>
+            </a:r>
+            <a:r>
+              <a:rPr lang="en-US" sz="1000" dirty="0">
+                <a:solidFill>
+                  <a:srgbClr val="8899AA"/>
+                </a:solidFill>
+                <a:hlinkClick r:id="rId7"/>
+              </a:rPr>
+              <a:t>operations per hour</a:t>
+            </a:r>
+            <a:r>
+              <a:rPr lang="en-US" sz="1000" dirty="0">
+                <a:solidFill>
+                  <a:srgbClr val="8899AA"/>
+                </a:solidFill>
+              </a:rPr>
+              <a:t>. You </a:t>
+            </a:r>
+            <a:r>
+              <a:rPr lang="en-US" sz="1000">
+                <a:solidFill>
+                  <a:srgbClr val="8899AA"/>
+                </a:solidFill>
+              </a:rPr>
+              <a:t>can scale </a:t>
+            </a:r>
+            <a:r>
+              <a:rPr lang="en-US" sz="1000" dirty="0">
+                <a:solidFill>
+                  <a:srgbClr val="8899AA"/>
+                </a:solidFill>
+              </a:rPr>
+              <a:t>horizontally with multiple instances.</a:t>
+            </a:r>
+          </a:p>
+          <a:p>
+            <a:pPr marL="171450" indent="-171450">
+              <a:buFont typeface="Courier New" panose="02070309020205020404" pitchFamily="49" charset="0"/>
+              <a:buChar char="o"/>
+            </a:pPr>
+            <a:endParaRPr lang="en-US" sz="1000" dirty="0">
+              <a:solidFill>
+                <a:srgbClr val="8899AA"/>
+              </a:solidFill>
+            </a:endParaRPr>
+          </a:p>
+          <a:p>
+            <a:pPr marL="171450" indent="-171450">
+              <a:buFont typeface="Courier New" panose="02070309020205020404" pitchFamily="49" charset="0"/>
+              <a:buChar char="o"/>
+            </a:pPr>
+            <a:r>
+              <a:rPr lang="en-US" sz="1000" dirty="0">
+                <a:solidFill>
+                  <a:srgbClr val="8899AA"/>
+                </a:solidFill>
+              </a:rPr>
+              <a:t>[4] Different file types (image, audio, video, text) have different size limits. 200 MB is a general estimate. Detailed limits are in the </a:t>
+            </a:r>
+            <a:r>
+              <a:rPr lang="en-US" sz="1000" dirty="0">
+                <a:solidFill>
+                  <a:srgbClr val="8899AA"/>
+                </a:solidFill>
+                <a:hlinkClick r:id="rId8"/>
+              </a:rPr>
+              <a:t>Service limits </a:t>
+            </a:r>
+            <a:r>
+              <a:rPr lang="en-US" sz="1000" dirty="0">
+                <a:solidFill>
+                  <a:srgbClr val="8899AA"/>
+                </a:solidFill>
+              </a:rPr>
+              <a:t>page.</a:t>
+            </a:r>
+          </a:p>
+          <a:p>
+            <a:pPr marL="171450" indent="-171450">
+              <a:buFont typeface="Courier New" panose="02070309020205020404" pitchFamily="49" charset="0"/>
+              <a:buChar char="o"/>
+            </a:pPr>
+            <a:endParaRPr lang="en-US" sz="1000" dirty="0">
+              <a:solidFill>
+                <a:srgbClr val="8899AA"/>
+              </a:solidFill>
+            </a:endParaRPr>
+          </a:p>
+          <a:p>
+            <a:pPr marL="171450" indent="-171450">
+              <a:buFont typeface="Courier New" panose="02070309020205020404" pitchFamily="49" charset="0"/>
+              <a:buChar char="o"/>
+            </a:pPr>
+            <a:r>
+              <a:rPr lang="en-US" sz="1000" dirty="0">
+                <a:solidFill>
+                  <a:srgbClr val="8899AA"/>
+                </a:solidFill>
+              </a:rPr>
+              <a:t>[5] M365 Exchange Online </a:t>
+            </a:r>
+            <a:r>
+              <a:rPr lang="en-US" sz="1000" dirty="0">
+                <a:solidFill>
+                  <a:srgbClr val="8899AA"/>
+                </a:solidFill>
+                <a:hlinkClick r:id="rId9"/>
+              </a:rPr>
+              <a:t>email receiving limits </a:t>
+            </a:r>
+            <a:r>
+              <a:rPr lang="en-US" sz="1000" dirty="0">
+                <a:solidFill>
+                  <a:srgbClr val="8899AA"/>
+                </a:solidFill>
+              </a:rPr>
+              <a:t>for a mailbox.</a:t>
+            </a:r>
+          </a:p>
+          <a:p>
+            <a:pPr marL="171450" indent="-171450">
+              <a:buFont typeface="Courier New" panose="02070309020205020404" pitchFamily="49" charset="0"/>
+              <a:buChar char="o"/>
+            </a:pPr>
+            <a:endParaRPr lang="en-US" sz="1000" dirty="0">
+              <a:solidFill>
+                <a:srgbClr val="8899AA"/>
+              </a:solidFill>
+            </a:endParaRPr>
+          </a:p>
+          <a:p>
+            <a:pPr marL="171450" indent="-171450">
+              <a:buFont typeface="Courier New" panose="02070309020205020404" pitchFamily="49" charset="0"/>
+              <a:buChar char="o"/>
+            </a:pPr>
+            <a:r>
+              <a:rPr lang="en-US" sz="1000" dirty="0">
+                <a:solidFill>
+                  <a:srgbClr val="8899AA"/>
+                </a:solidFill>
+              </a:rPr>
+              <a:t>[6] File attachment size limit details vary a little based on client/device/OS/encryption etc. Details are </a:t>
+            </a:r>
+            <a:r>
+              <a:rPr lang="en-US" sz="1000" dirty="0">
+                <a:solidFill>
+                  <a:srgbClr val="8899AA"/>
+                </a:solidFill>
+                <a:hlinkClick r:id="rId10"/>
+              </a:rPr>
+              <a:t>here</a:t>
+            </a:r>
+            <a:r>
+              <a:rPr lang="en-US" sz="1000" dirty="0">
+                <a:solidFill>
+                  <a:srgbClr val="8899AA"/>
+                </a:solidFill>
+              </a:rPr>
+              <a:t>.</a:t>
+            </a:r>
+          </a:p>
+        </p:txBody>
+      </p:sp>
+    </p:spTree>
+  </p:cSld>
+  <p:clrMapOvr>
+    <a:masterClrMapping/>
+  </p:clrMapOvr>
+</p:sld>
+</file>
+
+<file path=ppt/slides/slide4.xml><?xml version="1.0" encoding="utf-8"?>
+<p:sld xmlns:a="http://schemas.openxmlformats.org/drawingml/2006/main" xmlns:r="http://schemas.openxmlformats.org/officeDocument/2006/relationships" xmlns:p="http://schemas.openxmlformats.org/presentationml/2006/main">
+  <p:cSld>
+    <p:bg>
+      <p:bgPr>
         <a:solidFill>
           <a:srgbClr val="F4F7FB"/>
         </a:solidFill>
@@ -9700,8 +10440,8 @@
           </p:blipFill>
           <p:spPr>
             <a:xfrm>
-              <a:off x="603504" y="1563624"/>
-              <a:ext cx="274320" cy="274320"/>
+              <a:off x="624132" y="1563624"/>
+              <a:ext cx="233064" cy="274320"/>
             </a:xfrm>
             <a:prstGeom prst="rect">
               <a:avLst/>
@@ -9739,7 +10479,7 @@
                 <a:buNone/>
               </a:pPr>
               <a:r>
-                <a:rPr lang="en-US" sz="1200" dirty="0">
+                <a:rPr lang="en-US" sz="1200">
                   <a:solidFill>
                     <a:srgbClr val="16324A"/>
                   </a:solidFill>
@@ -9749,7 +10489,7 @@
                 </a:rPr>
                 <a:t>Mailbox to Queue</a:t>
               </a:r>
-              <a:endParaRPr lang="en-US" sz="1200" dirty="0"/>
+              <a:endParaRPr lang="en-US" sz="1200"/>
             </a:p>
           </p:txBody>
         </p:sp>
@@ -9786,7 +10526,7 @@
                 <a:buChar char="•"/>
               </a:pPr>
               <a:r>
-                <a:rPr lang="en-US" sz="1000" dirty="0">
+                <a:rPr lang="en-US" sz="1000">
                   <a:solidFill>
                     <a:srgbClr val="4D657A"/>
                   </a:solidFill>
@@ -9804,7 +10544,7 @@
                 <a:buChar char="•"/>
               </a:pPr>
               <a:r>
-                <a:rPr lang="en-US" sz="1000" dirty="0">
+                <a:rPr lang="en-US" sz="1000">
                   <a:solidFill>
                     <a:srgbClr val="4D657A"/>
                   </a:solidFill>
@@ -9900,8 +10640,8 @@
           </p:blipFill>
           <p:spPr>
             <a:xfrm>
-              <a:off x="603504" y="2432304"/>
-              <a:ext cx="274320" cy="274320"/>
+              <a:off x="624132" y="2432304"/>
+              <a:ext cx="233064" cy="274320"/>
             </a:xfrm>
             <a:prstGeom prst="rect">
               <a:avLst/>
@@ -9939,7 +10679,7 @@
                 <a:buNone/>
               </a:pPr>
               <a:r>
-                <a:rPr lang="en-US" sz="1200" dirty="0">
+                <a:rPr lang="en-US" sz="1200">
                   <a:solidFill>
                     <a:srgbClr val="16324A"/>
                   </a:solidFill>
@@ -9949,7 +10689,7 @@
                 </a:rPr>
                 <a:t>Queue Orchestration</a:t>
               </a:r>
-              <a:endParaRPr lang="en-US" sz="1200" dirty="0"/>
+              <a:endParaRPr lang="en-US" sz="1200"/>
             </a:p>
           </p:txBody>
         </p:sp>
@@ -9986,7 +10726,7 @@
                 <a:buChar char="•"/>
               </a:pPr>
               <a:r>
-                <a:rPr lang="en-US" sz="1000" dirty="0">
+                <a:rPr lang="en-US" sz="1000">
                   <a:solidFill>
                     <a:srgbClr val="4D657A"/>
                   </a:solidFill>
@@ -9996,7 +10736,7 @@
                 </a:rPr>
                 <a:t>Coordinates extraction pipeline</a:t>
               </a:r>
-              <a:endParaRPr lang="en-US" sz="1000" dirty="0"/>
+              <a:endParaRPr lang="en-US" sz="1000"/>
             </a:p>
           </p:txBody>
         </p:sp>
@@ -10083,8 +10823,8 @@
           </p:blipFill>
           <p:spPr>
             <a:xfrm>
-              <a:off x="603504" y="3300984"/>
-              <a:ext cx="274320" cy="274320"/>
+              <a:off x="624132" y="3300984"/>
+              <a:ext cx="233064" cy="274320"/>
             </a:xfrm>
             <a:prstGeom prst="rect">
               <a:avLst/>
@@ -10122,7 +10862,7 @@
                 <a:buNone/>
               </a:pPr>
               <a:r>
-                <a:rPr lang="en-US" sz="1200" dirty="0">
+                <a:rPr lang="en-US" sz="1200">
                   <a:solidFill>
                     <a:srgbClr val="16324A"/>
                   </a:solidFill>
@@ -10132,7 +10872,7 @@
                 </a:rPr>
                 <a:t>CU Queue to DB</a:t>
               </a:r>
-              <a:endParaRPr lang="en-US" sz="1200" dirty="0"/>
+              <a:endParaRPr lang="en-US" sz="1200"/>
             </a:p>
           </p:txBody>
         </p:sp>
@@ -10169,7 +10909,7 @@
                 <a:buChar char="•"/>
               </a:pPr>
               <a:r>
-                <a:rPr lang="en-US" sz="1000" dirty="0">
+                <a:rPr lang="en-US" sz="1000">
                   <a:solidFill>
                     <a:srgbClr val="4D657A"/>
                   </a:solidFill>
@@ -10186,7 +10926,7 @@
                 <a:buChar char="•"/>
               </a:pPr>
               <a:r>
-                <a:rPr lang="en-US" sz="1000" dirty="0">
+                <a:rPr lang="en-US" sz="1000">
                   <a:solidFill>
                     <a:srgbClr val="4D657A"/>
                   </a:solidFill>
@@ -10196,7 +10936,7 @@
                 </a:rPr>
                 <a:t>Persists CU analysis output</a:t>
               </a:r>
-              <a:endParaRPr lang="en-US" sz="700" dirty="0"/>
+              <a:endParaRPr lang="en-US" sz="700"/>
             </a:p>
           </p:txBody>
         </p:sp>
@@ -12499,7 +13239,7 @@
                   <a:buNone/>
                 </a:pPr>
                 <a:r>
-                  <a:rPr lang="en-US" sz="1200" dirty="0">
+                  <a:rPr lang="en-US" sz="1200">
                     <a:solidFill>
                       <a:srgbClr val="16324A"/>
                     </a:solidFill>
@@ -12509,7 +13249,7 @@
                   </a:rPr>
                   <a:t>Autonomous processing</a:t>
                 </a:r>
-                <a:endParaRPr lang="en-US" sz="1200" dirty="0"/>
+                <a:endParaRPr lang="en-US" sz="1200"/>
               </a:p>
             </p:txBody>
           </p:sp>
@@ -12546,7 +13286,7 @@
                   <a:buChar char="•"/>
                 </a:pPr>
                 <a:r>
-                  <a:rPr lang="en-US" sz="1000" dirty="0">
+                  <a:rPr lang="en-US" sz="1000">
                     <a:solidFill>
                       <a:srgbClr val="4D657A"/>
                     </a:solidFill>
@@ -12563,7 +13303,7 @@
                   <a:buChar char="•"/>
                 </a:pPr>
                 <a:r>
-                  <a:rPr lang="en-US" sz="1000" dirty="0">
+                  <a:rPr lang="en-US" sz="1000">
                     <a:solidFill>
                       <a:srgbClr val="4D657A"/>
                     </a:solidFill>
@@ -12572,7 +13312,7 @@
                   </a:rPr>
                   <a:t>Background processing</a:t>
                 </a:r>
-                <a:endParaRPr lang="en-US" sz="700" dirty="0"/>
+                <a:endParaRPr lang="en-US" sz="700"/>
               </a:p>
             </p:txBody>
           </p:sp>
@@ -12599,8 +13339,8 @@
           </p:blipFill>
           <p:spPr>
             <a:xfrm>
-              <a:off x="5900798" y="3035808"/>
-              <a:ext cx="274320" cy="274320"/>
+              <a:off x="5919550" y="3035808"/>
+              <a:ext cx="236815" cy="274320"/>
             </a:xfrm>
             <a:prstGeom prst="rect">
               <a:avLst/>
@@ -12696,8 +13436,8 @@
           </p:blipFill>
           <p:spPr>
             <a:xfrm>
-              <a:off x="570936" y="1593154"/>
-              <a:ext cx="255059" cy="274320"/>
+              <a:off x="570936" y="1602784"/>
+              <a:ext cx="255059" cy="255059"/>
             </a:xfrm>
             <a:prstGeom prst="rect">
               <a:avLst/>
@@ -12735,7 +13475,7 @@
                 <a:buNone/>
               </a:pPr>
               <a:r>
-                <a:rPr lang="en-US" sz="1200" dirty="0">
+                <a:rPr lang="en-US" sz="1200">
                   <a:solidFill>
                     <a:srgbClr val="16324A"/>
                   </a:solidFill>
@@ -12745,7 +13485,7 @@
                 </a:rPr>
                 <a:t>M365 Mailbox</a:t>
               </a:r>
-              <a:endParaRPr lang="en-US" sz="1200" dirty="0"/>
+              <a:endParaRPr lang="en-US" sz="1200"/>
             </a:p>
           </p:txBody>
         </p:sp>
@@ -12782,7 +13522,7 @@
                 <a:buChar char="•"/>
               </a:pPr>
               <a:r>
-                <a:rPr lang="en-US" sz="1000" dirty="0">
+                <a:rPr lang="en-US" sz="1000">
                   <a:solidFill>
                     <a:srgbClr val="4D657A"/>
                   </a:solidFill>
@@ -12799,7 +13539,7 @@
                 <a:buChar char="•"/>
               </a:pPr>
               <a:r>
-                <a:rPr lang="en-US" sz="1000" dirty="0">
+                <a:rPr lang="en-US" sz="1000">
                   <a:solidFill>
                     <a:srgbClr val="4D657A"/>
                   </a:solidFill>
@@ -12809,7 +13549,7 @@
                 </a:rPr>
                 <a:t>Access via MS Graph API</a:t>
               </a:r>
-              <a:endParaRPr lang="en-US" sz="1000" dirty="0">
+              <a:endParaRPr lang="en-US" sz="1000">
                 <a:solidFill>
                   <a:srgbClr val="4D657A"/>
                 </a:solidFill>
@@ -12824,7 +13564,7 @@
                 <a:buChar char="•"/>
               </a:pPr>
               <a:r>
-                <a:rPr lang="en-US" sz="1000" dirty="0">
+                <a:rPr lang="en-US" sz="1000">
                   <a:solidFill>
                     <a:srgbClr val="4D657A"/>
                   </a:solidFill>
@@ -12834,7 +13574,7 @@
                 </a:rPr>
                 <a:t>Secured access</a:t>
               </a:r>
-              <a:endParaRPr lang="en-US" sz="1000" dirty="0">
+              <a:endParaRPr lang="en-US" sz="1000">
                 <a:solidFill>
                   <a:srgbClr val="4D657A"/>
                 </a:solidFill>
@@ -13139,8 +13879,8 @@
           </p:blipFill>
           <p:spPr>
             <a:xfrm>
-              <a:off x="2307502" y="4169477"/>
-              <a:ext cx="187457" cy="201612"/>
+              <a:off x="2307502" y="4176554"/>
+              <a:ext cx="187457" cy="187457"/>
             </a:xfrm>
             <a:prstGeom prst="rect">
               <a:avLst/>
@@ -13178,7 +13918,7 @@
                 <a:buNone/>
               </a:pPr>
               <a:r>
-                <a:rPr lang="en-US" sz="1200" dirty="0">
+                <a:rPr lang="en-US" sz="1200">
                   <a:solidFill>
                     <a:srgbClr val="16324A"/>
                   </a:solidFill>
@@ -13188,7 +13928,7 @@
                 </a:rPr>
                 <a:t>Azure Storage Blob</a:t>
               </a:r>
-              <a:endParaRPr lang="en-US" sz="1200" dirty="0"/>
+              <a:endParaRPr lang="en-US" sz="1200"/>
             </a:p>
           </p:txBody>
         </p:sp>
@@ -13225,7 +13965,7 @@
                 <a:buChar char="•"/>
               </a:pPr>
               <a:r>
-                <a:rPr lang="en-US" sz="1000" dirty="0">
+                <a:rPr lang="en-US" sz="1000">
                   <a:solidFill>
                     <a:srgbClr val="4D657A"/>
                   </a:solidFill>
@@ -13479,8 +14219,8 @@
           </p:blipFill>
           <p:spPr>
             <a:xfrm>
-              <a:off x="419149" y="4169477"/>
-              <a:ext cx="187457" cy="201613"/>
+              <a:off x="419149" y="4176555"/>
+              <a:ext cx="187457" cy="187457"/>
             </a:xfrm>
             <a:prstGeom prst="rect">
               <a:avLst/>
@@ -13518,7 +14258,7 @@
                 <a:buNone/>
               </a:pPr>
               <a:r>
-                <a:rPr lang="en-US" sz="1200" dirty="0">
+                <a:rPr lang="en-US" sz="1200">
                   <a:solidFill>
                     <a:srgbClr val="16324A"/>
                   </a:solidFill>
@@ -13528,7 +14268,7 @@
                 </a:rPr>
                 <a:t>Azure Storage Table</a:t>
               </a:r>
-              <a:endParaRPr lang="en-US" sz="1200" dirty="0"/>
+              <a:endParaRPr lang="en-US" sz="1200"/>
             </a:p>
           </p:txBody>
         </p:sp>
@@ -13564,7 +14304,7 @@
                 <a:buChar char="•"/>
               </a:pPr>
               <a:r>
-                <a:rPr lang="en-US" sz="1000" dirty="0">
+                <a:rPr lang="en-US" sz="1000">
                   <a:solidFill>
                     <a:srgbClr val="4D657A"/>
                   </a:solidFill>
@@ -13574,7 +14314,7 @@
                 </a:rPr>
                 <a:t>Conversation ids</a:t>
               </a:r>
-              <a:endParaRPr lang="en-US" sz="700" dirty="0">
+              <a:endParaRPr lang="en-US" sz="700">
                 <a:solidFill>
                   <a:srgbClr val="4D657A"/>
                 </a:solidFill>
@@ -13674,8 +14414,8 @@
           </p:blipFill>
           <p:spPr>
             <a:xfrm>
-              <a:off x="4153701" y="4169477"/>
-              <a:ext cx="187457" cy="206588"/>
+              <a:off x="4153701" y="4179042"/>
+              <a:ext cx="187457" cy="187457"/>
             </a:xfrm>
             <a:prstGeom prst="rect">
               <a:avLst/>
@@ -13713,7 +14453,7 @@
                 <a:buNone/>
               </a:pPr>
               <a:r>
-                <a:rPr lang="en-US" sz="1200" dirty="0">
+                <a:rPr lang="en-US" sz="1200">
                   <a:solidFill>
                     <a:srgbClr val="16324A"/>
                   </a:solidFill>
@@ -13723,7 +14463,7 @@
                 </a:rPr>
                 <a:t>Azure Storage Queue</a:t>
               </a:r>
-              <a:endParaRPr lang="en-US" sz="1200" dirty="0"/>
+              <a:endParaRPr lang="en-US" sz="1200"/>
             </a:p>
           </p:txBody>
         </p:sp>
@@ -13760,7 +14500,7 @@
                 <a:buChar char="•"/>
               </a:pPr>
               <a:r>
-                <a:rPr lang="en-US" sz="1000" dirty="0">
+                <a:rPr lang="en-US" sz="1000">
                   <a:solidFill>
                     <a:srgbClr val="4D657A"/>
                   </a:solidFill>

</xml_diff>